<commit_message>
Visual polish: pre-seed deck + global report with India-first roadmap
</commit_message>
<xml_diff>
--- a/A priyam ka patora/Startup Ideas/03 - Ecommerce Hub/Ecommerce_Hub_PreSeed_Deck.pptx
+++ b/A priyam ka patora/Startup Ideas/03 - Ecommerce Hub/Ecommerce_Hub_PreSeed_Deck.pptx
@@ -18,9 +18,10 @@
     <p:sldId id="266" r:id="rId12"/>
     <p:sldId id="267" r:id="rId13"/>
     <p:sldId id="268" r:id="rId14"/>
+    <p:sldId id="269" r:id="rId15"/>
   </p:sldIdLst>
   <p:notesMasterIdLst>
-    <p:notesMasterId r:id="rId15"/>
+    <p:notesMasterId r:id="rId16"/>
   </p:notesMasterIdLst>
   <p:sldSz cx="12192000" cy="6858000"/>
   <p:notesSz cx="6858000" cy="12192000"/>
@@ -117,6 +118,265 @@
     </a:lvl9pPr>
   </p:defaultTextStyle>
 </p:presentation>
+</file>
+
+<file path=ppt/charts/chart1.xml><?xml version="1.0" encoding="utf-8"?>
+<c:chartSpace xmlns:c="http://schemas.openxmlformats.org/drawingml/2006/chart" xmlns:a="http://schemas.openxmlformats.org/drawingml/2006/main" xmlns:r="http://schemas.openxmlformats.org/officeDocument/2006/relationships">
+  <c:date1904 val="0"/>
+  <c:roundedCorners val="1"/>
+  <c:chart>
+    <c:autoTitleDeleted val="1"/>
+    <c:plotArea>
+      <c:layout/>
+      <c:areaChart>
+        <c:varyColors val="0"/>
+        <c:ser>
+          <c:idx val="0"/>
+          <c:order val="0"/>
+          <c:tx>
+            <c:strRef>
+              <c:f>Sheet1!$B$1</c:f>
+              <c:strCache>
+                <c:ptCount val="1"/>
+                <c:pt idx="0">
+                  <c:v>India D2C market ($B)</c:v>
+                </c:pt>
+              </c:strCache>
+            </c:strRef>
+          </c:tx>
+          <c:spPr>
+            <a:solidFill>
+              <a:srgbClr val="2F3C7E"/>
+            </a:solidFill>
+            <a:effectLst/>
+          </c:spPr>
+          <c:invertIfNegative val="0"/>
+          <c:dLbls>
+            <c:numFmt formatCode="#,##0" sourceLinked="0"/>
+            <c:txPr>
+              <a:bodyPr/>
+              <a:lstStyle/>
+              <a:p>
+                <a:pPr>
+                  <a:defRPr b="0" i="0" strike="noStrike" sz="1200" u="none">
+                    <a:solidFill>
+                      <a:srgbClr val="2F3C7E"/>
+                    </a:solidFill>
+                    <a:latin typeface="Arial"/>
+                  </a:defRPr>
+                </a:pPr>
+              </a:p>
+            </c:txPr>
+            <c:showLegendKey val="0"/>
+            <c:showVal val="0"/>
+            <c:showCatName val="0"/>
+            <c:showSerName val="0"/>
+            <c:showPercent val="0"/>
+            <c:showBubbleSize val="0"/>
+            <c:showLeaderLines val="0"/>
+          </c:dLbls>
+          <c:cat>
+            <c:multiLvlStrRef>
+              <c:f>Sheet1!$A$2:$A$7</c:f>
+              <c:multiLvlStrCache>
+                <c:ptCount val="6"/>
+                <c:lvl>
+                  <c:pt idx="0">
+                    <c:v>2026</c:v>
+                  </c:pt>
+                  <c:pt idx="1">
+                    <c:v>2027</c:v>
+                  </c:pt>
+                  <c:pt idx="2">
+                    <c:v>2028</c:v>
+                  </c:pt>
+                  <c:pt idx="3">
+                    <c:v>2029</c:v>
+                  </c:pt>
+                  <c:pt idx="4">
+                    <c:v>2030</c:v>
+                  </c:pt>
+                  <c:pt idx="5">
+                    <c:v>2031</c:v>
+                  </c:pt>
+                </c:lvl>
+              </c:multiLvlStrCache>
+            </c:multiLvlStrRef>
+          </c:cat>
+          <c:val>
+            <c:numRef>
+              <c:f>Sheet1!$B$2:$B$7</c:f>
+              <c:numCache>
+                <c:formatCode>General</c:formatCode>
+                <c:ptCount val="6"/>
+                <c:pt idx="0">
+                  <c:v>108.76</c:v>
+                </c:pt>
+                <c:pt idx="1">
+                  <c:v>135.2</c:v>
+                </c:pt>
+                <c:pt idx="2">
+                  <c:v>168</c:v>
+                </c:pt>
+                <c:pt idx="3">
+                  <c:v>208.8</c:v>
+                </c:pt>
+                <c:pt idx="4">
+                  <c:v>259.6</c:v>
+                </c:pt>
+                <c:pt idx="5">
+                  <c:v>322.1</c:v>
+                </c:pt>
+              </c:numCache>
+            </c:numRef>
+          </c:val>
+        </c:ser>
+        <c:dLbls>
+          <c:numFmt formatCode="#,##0" sourceLinked="0"/>
+          <c:txPr>
+            <a:bodyPr/>
+            <a:lstStyle/>
+            <a:p>
+              <a:pPr>
+                <a:defRPr b="0" i="0" strike="noStrike" sz="1200" u="none">
+                  <a:solidFill>
+                    <a:srgbClr val="2F3C7E"/>
+                  </a:solidFill>
+                  <a:latin typeface="Arial"/>
+                </a:defRPr>
+              </a:pPr>
+            </a:p>
+          </c:txPr>
+          <c:showLegendKey val="0"/>
+          <c:showVal val="0"/>
+          <c:showCatName val="0"/>
+          <c:showSerName val="0"/>
+          <c:showPercent val="0"/>
+          <c:showBubbleSize val="0"/>
+          <c:showLeaderLines val="0"/>
+        </c:dLbls>
+        <c:axId val="2094734554"/>
+        <c:axId val="2094734552"/>
+        <c:axId val="2094734556"/>
+      </c:areaChart>
+      <c:catAx>
+        <c:axId val="2094734554"/>
+        <c:scaling>
+          <c:orientation val="minMax"/>
+        </c:scaling>
+        <c:delete val="0"/>
+        <c:axPos val="b"/>
+        <c:numFmt formatCode="General" sourceLinked="1"/>
+        <c:majorTickMark val="out"/>
+        <c:minorTickMark val="none"/>
+        <c:tickLblPos val="low"/>
+        <c:spPr>
+          <a:ln w="12700" cap="flat">
+            <a:solidFill>
+              <a:srgbClr val="888888"/>
+            </a:solidFill>
+            <a:prstDash val="solid"/>
+            <a:round/>
+          </a:ln>
+        </c:spPr>
+        <c:txPr>
+          <a:bodyPr/>
+          <a:lstStyle/>
+          <a:p>
+            <a:pPr>
+              <a:defRPr sz="1200" b="0" i="0" u="none" strike="noStrike">
+                <a:solidFill>
+                  <a:srgbClr val="6B7280"/>
+                </a:solidFill>
+                <a:latin typeface="Arial"/>
+              </a:defRPr>
+            </a:pPr>
+            <a:endParaRPr lang="en-US"/>
+          </a:p>
+        </c:txPr>
+        <c:crossAx val="2094734552"/>
+        <c:crosses val="autoZero"/>
+        <c:auto val="1"/>
+        <c:lblAlgn val="ctr"/>
+        <c:noMultiLvlLbl val="1"/>
+      </c:catAx>
+      <c:valAx>
+        <c:axId val="2094734552"/>
+        <c:scaling>
+          <c:orientation val="minMax"/>
+          <c:min val="0"/>
+        </c:scaling>
+        <c:delete val="0"/>
+        <c:axPos val="l"/>
+        <c:majorGridlines>
+          <c:spPr>
+            <a:ln w="9525" cap="flat">
+              <a:solidFill>
+                <a:srgbClr val="E4E4EC"/>
+              </a:solidFill>
+              <a:prstDash val="solid"/>
+              <a:round/>
+            </a:ln>
+          </c:spPr>
+        </c:majorGridlines>
+        <c:numFmt formatCode="General" sourceLinked="0"/>
+        <c:majorTickMark val="out"/>
+        <c:minorTickMark val="none"/>
+        <c:tickLblPos val="nextTo"/>
+        <c:spPr>
+          <a:ln w="12700" cap="flat">
+            <a:solidFill>
+              <a:srgbClr val="888888"/>
+            </a:solidFill>
+            <a:prstDash val="solid"/>
+            <a:round/>
+          </a:ln>
+        </c:spPr>
+        <c:txPr>
+          <a:bodyPr/>
+          <a:lstStyle/>
+          <a:p>
+            <a:pPr>
+              <a:defRPr sz="1200" b="0" i="0" u="none" strike="noStrike">
+                <a:solidFill>
+                  <a:srgbClr val="6B7280"/>
+                </a:solidFill>
+                <a:latin typeface="Arial"/>
+              </a:defRPr>
+            </a:pPr>
+            <a:endParaRPr lang="en-US"/>
+          </a:p>
+        </c:txPr>
+        <c:crossAx val="2094734554"/>
+        <c:crosses val="autoZero"/>
+        <c:crossBetween val="between"/>
+      </c:valAx>
+      <c:spPr>
+        <a:solidFill>
+          <a:srgbClr val="F7F7F6"/>
+        </a:solidFill>
+        <a:ln>
+          <a:noFill/>
+        </a:ln>
+        <a:effectLst/>
+      </c:spPr>
+    </c:plotArea>
+    <c:plotVisOnly val="1"/>
+    <c:dispBlanksAs val="span"/>
+  </c:chart>
+  <c:spPr>
+    <a:solidFill>
+      <a:srgbClr val="F7F7F6"/>
+    </a:solidFill>
+    <a:ln>
+      <a:noFill/>
+    </a:ln>
+    <a:effectLst/>
+  </c:spPr>
+  <c:externalData r:id="rId1">
+    <c:autoUpdate val="0"/>
+  </c:externalData>
+</c:chartSpace>
 </file>
 
 <file path=ppt/notesMasters/notesMaster1.xml><?xml version="1.0" encoding="utf-8"?>
@@ -890,6 +1150,94 @@
             <a:fld id="{F7021451-1387-4CA6-816F-3879F97B5CBC}" type="slidenum">
               <a:rPr lang="en-US"/>
               <a:t>13</a:t>
+            </a:fld>
+            <a:endParaRPr lang="en-US"/>
+          </a:p>
+        </p:txBody>
+      </p:sp>
+    </p:spTree>
+    <p:extLst>
+      <p:ext uri="{BB962C8B-B14F-4D97-AF65-F5344CB8AC3E}">
+        <p14:creationId xmlns:p14="http://schemas.microsoft.com/office/powerpoint/2010/main" val="1024086991"/>
+      </p:ext>
+    </p:extLst>
+  </p:cSld>
+  <p:clrMapOvr>
+    <a:masterClrMapping/>
+  </p:clrMapOvr>
+</p:notes>
+</file>
+
+<file path=ppt/notesSlides/notesSlide14.xml><?xml version="1.0" encoding="utf-8"?>
+<p:notes xmlns:a="http://schemas.openxmlformats.org/drawingml/2006/main" xmlns:r="http://schemas.openxmlformats.org/officeDocument/2006/relationships" xmlns:p="http://schemas.openxmlformats.org/presentationml/2006/main">
+  <p:cSld>
+    <p:spTree>
+      <p:nvGrpSpPr>
+        <p:cNvPr id="1" name=""/>
+        <p:cNvGrpSpPr/>
+        <p:nvPr/>
+      </p:nvGrpSpPr>
+      <p:grpSpPr>
+        <a:xfrm>
+          <a:off x="0" y="0"/>
+          <a:ext cx="0" cy="0"/>
+          <a:chOff x="0" y="0"/>
+          <a:chExt cx="0" cy="0"/>
+        </a:xfrm>
+      </p:grpSpPr>
+      <p:sp>
+        <p:nvSpPr>
+          <p:cNvPr id="2" name="Slide Image Placeholder 1"/>
+          <p:cNvSpPr>
+            <a:spLocks noGrp="1" noRot="1" noChangeAspect="1"/>
+          </p:cNvSpPr>
+          <p:nvPr>
+            <p:ph type="sldImg"/>
+          </p:nvPr>
+        </p:nvSpPr>
+        <p:spPr/>
+      </p:sp>
+      <p:sp>
+        <p:nvSpPr>
+          <p:cNvPr id="3" name="Notes Placeholder 2"/>
+          <p:cNvSpPr>
+            <a:spLocks noGrp="1"/>
+          </p:cNvSpPr>
+          <p:nvPr>
+            <p:ph type="body" idx="1"/>
+          </p:nvPr>
+        </p:nvSpPr>
+        <p:spPr/>
+        <p:txBody>
+          <a:bodyPr/>
+          <a:lstStyle/>
+          <a:p>
+            <a:r>
+              <a:rPr lang="en-US" dirty="0"/>
+              <a:t/>
+            </a:r>
+            <a:endParaRPr lang="en-US" dirty="0"/>
+          </a:p>
+        </p:txBody>
+      </p:sp>
+      <p:sp>
+        <p:nvSpPr>
+          <p:cNvPr id="4" name="Slide Number Placeholder 3"/>
+          <p:cNvSpPr>
+            <a:spLocks noGrp="1"/>
+          </p:cNvSpPr>
+          <p:nvPr>
+            <p:ph type="sldNum" sz="quarter" idx="10"/>
+          </p:nvPr>
+        </p:nvSpPr>
+        <p:spPr/>
+        <p:txBody>
+          <a:bodyPr/>
+          <a:lstStyle/>
+          <a:p>
+            <a:fld id="{F7021451-1387-4CA6-816F-3879F97B5CBC}" type="slidenum">
+              <a:rPr lang="en-US"/>
+              <a:t>14</a:t>
             </a:fld>
             <a:endParaRPr lang="en-US"/>
           </a:p>
@@ -2242,6 +2590,1436 @@
     <p:bg>
       <p:bgPr>
         <a:solidFill>
+          <a:srgbClr val="1F2A5C"/>
+        </a:solidFill>
+      </p:bgPr>
+    </p:bg>
+    <p:spTree>
+      <p:nvGrpSpPr>
+        <p:cNvPr id="1" name=""/>
+        <p:cNvGrpSpPr/>
+        <p:nvPr/>
+      </p:nvGrpSpPr>
+      <p:grpSpPr>
+        <a:xfrm>
+          <a:off x="0" y="0"/>
+          <a:ext cx="0" cy="0"/>
+          <a:chOff x="0" y="0"/>
+          <a:chExt cx="0" cy="0"/>
+        </a:xfrm>
+      </p:grpSpPr>
+      <p:sp>
+        <p:nvSpPr>
+          <p:cNvPr id="2" name="Text 0"/>
+          <p:cNvSpPr txBox="1"/>
+          <p:nvPr/>
+        </p:nvSpPr>
+        <p:spPr>
+          <a:xfrm>
+            <a:off x="548640" y="384048"/>
+            <a:ext cx="8229600" cy="365760"/>
+          </a:xfrm>
+          <a:prstGeom prst="rect">
+            <a:avLst/>
+          </a:prstGeom>
+          <a:noFill/>
+          <a:ln/>
+        </p:spPr>
+        <p:txBody>
+          <a:bodyPr wrap="square" lIns="0" tIns="0" rIns="0" bIns="0" rtlCol="0" anchor="ctr"/>
+          <a:lstStyle/>
+          <a:p>
+            <a:pPr indent="0" marL="0">
+              <a:buNone/>
+            </a:pPr>
+            <a:r>
+              <a:rPr lang="en-US" sz="1300" b="1" spc="200" kern="0" dirty="0">
+                <a:solidFill>
+                  <a:srgbClr val="F9E795"/>
+                </a:solidFill>
+                <a:latin typeface="Calibri" pitchFamily="34" charset="0"/>
+                <a:ea typeface="Calibri" pitchFamily="34" charset="-122"/>
+                <a:cs typeface="Calibri" pitchFamily="34" charset="-120"/>
+              </a:rPr>
+              <a:t>EXPANSION ROADMAP</a:t>
+            </a:r>
+            <a:endParaRPr lang="en-US" sz="1300" dirty="0"/>
+          </a:p>
+        </p:txBody>
+      </p:sp>
+      <p:sp>
+        <p:nvSpPr>
+          <p:cNvPr id="3" name="Text 1"/>
+          <p:cNvSpPr txBox="1"/>
+          <p:nvPr/>
+        </p:nvSpPr>
+        <p:spPr>
+          <a:xfrm>
+            <a:off x="548640" y="713232"/>
+            <a:ext cx="10881360" cy="868680"/>
+          </a:xfrm>
+          <a:prstGeom prst="rect">
+            <a:avLst/>
+          </a:prstGeom>
+          <a:noFill/>
+          <a:ln/>
+        </p:spPr>
+        <p:txBody>
+          <a:bodyPr wrap="square" lIns="0" tIns="0" rIns="0" bIns="0" rtlCol="0" anchor="ctr"/>
+          <a:lstStyle/>
+          <a:p>
+            <a:pPr indent="0" marL="0">
+              <a:buNone/>
+            </a:pPr>
+            <a:r>
+              <a:rPr lang="en-US" sz="3000" b="1" dirty="0">
+                <a:solidFill>
+                  <a:srgbClr val="FFFFFF"/>
+                </a:solidFill>
+                <a:latin typeface="Cambria" pitchFamily="34" charset="0"/>
+                <a:ea typeface="Cambria" pitchFamily="34" charset="-122"/>
+                <a:cs typeface="Cambria" pitchFamily="34" charset="-120"/>
+              </a:rPr>
+              <a:t>India first, earned — not global, assumed</a:t>
+            </a:r>
+            <a:endParaRPr lang="en-US" sz="3000" dirty="0"/>
+          </a:p>
+        </p:txBody>
+      </p:sp>
+      <p:sp>
+        <p:nvSpPr>
+          <p:cNvPr id="4" name="Text 2"/>
+          <p:cNvSpPr txBox="1"/>
+          <p:nvPr/>
+        </p:nvSpPr>
+        <p:spPr>
+          <a:xfrm>
+            <a:off x="548640" y="1481328"/>
+            <a:ext cx="10881360" cy="457200"/>
+          </a:xfrm>
+          <a:prstGeom prst="rect">
+            <a:avLst/>
+          </a:prstGeom>
+          <a:noFill/>
+          <a:ln/>
+        </p:spPr>
+        <p:txBody>
+          <a:bodyPr wrap="square" lIns="0" tIns="0" rIns="0" bIns="0" rtlCol="0" anchor="ctr"/>
+          <a:lstStyle/>
+          <a:p>
+            <a:pPr indent="0" marL="0">
+              <a:buNone/>
+            </a:pPr>
+            <a:r>
+              <a:rPr lang="en-US" sz="1300" dirty="0">
+                <a:solidFill>
+                  <a:srgbClr val="C9CEE8"/>
+                </a:solidFill>
+                <a:latin typeface="Calibri" pitchFamily="34" charset="0"/>
+                <a:ea typeface="Calibri" pitchFamily="34" charset="-122"/>
+                <a:cs typeface="Calibri" pitchFamily="34" charset="-120"/>
+              </a:rPr>
+              <a:t>The global D2C category is worth $8.5T in 2026, heading to $33.5T by 2033 (Grand View Research). India is the proven beachhead into that category, not its ceiling.</a:t>
+            </a:r>
+            <a:endParaRPr lang="en-US" sz="1300" dirty="0"/>
+          </a:p>
+        </p:txBody>
+      </p:sp>
+      <p:sp>
+        <p:nvSpPr>
+          <p:cNvPr id="5" name="Shape 3"/>
+          <p:cNvSpPr/>
+          <p:nvPr/>
+        </p:nvSpPr>
+        <p:spPr>
+          <a:xfrm>
+            <a:off x="548640" y="2331720"/>
+            <a:ext cx="2029968" cy="3429000"/>
+          </a:xfrm>
+          <a:prstGeom prst="roundRect">
+            <a:avLst>
+              <a:gd name="adj" fmla="val 4505"/>
+            </a:avLst>
+          </a:prstGeom>
+          <a:solidFill>
+            <a:srgbClr val="2F3C7E"/>
+          </a:solidFill>
+          <a:ln w="19050">
+            <a:solidFill>
+              <a:srgbClr val="F96167"/>
+            </a:solidFill>
+            <a:prstDash val="solid"/>
+          </a:ln>
+        </p:spPr>
+      </p:sp>
+      <p:sp>
+        <p:nvSpPr>
+          <p:cNvPr id="6" name="Text 4"/>
+          <p:cNvSpPr txBox="1"/>
+          <p:nvPr/>
+        </p:nvSpPr>
+        <p:spPr>
+          <a:xfrm>
+            <a:off x="731520" y="2496312"/>
+            <a:ext cx="914400" cy="365760"/>
+          </a:xfrm>
+          <a:prstGeom prst="rect">
+            <a:avLst/>
+          </a:prstGeom>
+          <a:noFill/>
+          <a:ln/>
+        </p:spPr>
+        <p:txBody>
+          <a:bodyPr wrap="square" lIns="0" tIns="0" rIns="0" bIns="0" rtlCol="0" anchor="ctr"/>
+          <a:lstStyle/>
+          <a:p>
+            <a:pPr indent="0" marL="0">
+              <a:buNone/>
+            </a:pPr>
+            <a:r>
+              <a:rPr lang="en-US" sz="1500" b="1" dirty="0">
+                <a:solidFill>
+                  <a:srgbClr val="F96167"/>
+                </a:solidFill>
+                <a:latin typeface="Cambria" pitchFamily="34" charset="0"/>
+                <a:ea typeface="Cambria" pitchFamily="34" charset="-122"/>
+                <a:cs typeface="Cambria" pitchFamily="34" charset="-120"/>
+              </a:rPr>
+              <a:t>01</a:t>
+            </a:r>
+            <a:endParaRPr lang="en-US" sz="1500" dirty="0"/>
+          </a:p>
+        </p:txBody>
+      </p:sp>
+      <p:sp>
+        <p:nvSpPr>
+          <p:cNvPr id="7" name="Text 5"/>
+          <p:cNvSpPr txBox="1"/>
+          <p:nvPr/>
+        </p:nvSpPr>
+        <p:spPr>
+          <a:xfrm>
+            <a:off x="731520" y="2880360"/>
+            <a:ext cx="1664208" cy="594360"/>
+          </a:xfrm>
+          <a:prstGeom prst="rect">
+            <a:avLst/>
+          </a:prstGeom>
+          <a:noFill/>
+          <a:ln/>
+        </p:spPr>
+        <p:txBody>
+          <a:bodyPr wrap="square" lIns="0" tIns="0" rIns="0" bIns="0" rtlCol="0" anchor="ctr"/>
+          <a:lstStyle/>
+          <a:p>
+            <a:pPr indent="0" marL="0">
+              <a:lnSpc>
+                <a:spcPct val="110000"/>
+              </a:lnSpc>
+              <a:buNone/>
+            </a:pPr>
+            <a:r>
+              <a:rPr lang="en-US" sz="1400" b="1" dirty="0">
+                <a:solidFill>
+                  <a:srgbClr val="FFFFFF"/>
+                </a:solidFill>
+                <a:latin typeface="Calibri" pitchFamily="34" charset="0"/>
+                <a:ea typeface="Calibri" pitchFamily="34" charset="-122"/>
+                <a:cs typeface="Calibri" pitchFamily="34" charset="-120"/>
+              </a:rPr>
+              <a:t>Validate</a:t>
+            </a:r>
+            <a:endParaRPr lang="en-US" sz="1400" dirty="0"/>
+          </a:p>
+        </p:txBody>
+      </p:sp>
+      <p:sp>
+        <p:nvSpPr>
+          <p:cNvPr id="8" name="Text 6"/>
+          <p:cNvSpPr txBox="1"/>
+          <p:nvPr/>
+        </p:nvSpPr>
+        <p:spPr>
+          <a:xfrm>
+            <a:off x="731520" y="3502152"/>
+            <a:ext cx="1664208" cy="274320"/>
+          </a:xfrm>
+          <a:prstGeom prst="rect">
+            <a:avLst/>
+          </a:prstGeom>
+          <a:noFill/>
+          <a:ln/>
+        </p:spPr>
+        <p:txBody>
+          <a:bodyPr wrap="square" lIns="0" tIns="0" rIns="0" bIns="0" rtlCol="0" anchor="ctr"/>
+          <a:lstStyle/>
+          <a:p>
+            <a:pPr indent="0" marL="0">
+              <a:buNone/>
+            </a:pPr>
+            <a:r>
+              <a:rPr lang="en-US" sz="1000" i="1" dirty="0">
+                <a:solidFill>
+                  <a:srgbClr val="FFD9DA"/>
+                </a:solidFill>
+                <a:latin typeface="Calibri" pitchFamily="34" charset="0"/>
+                <a:ea typeface="Calibri" pitchFamily="34" charset="-122"/>
+                <a:cs typeface="Calibri" pitchFamily="34" charset="-120"/>
+              </a:rPr>
+              <a:t>Sep–Oct 2026</a:t>
+            </a:r>
+            <a:endParaRPr lang="en-US" sz="1000" dirty="0"/>
+          </a:p>
+        </p:txBody>
+      </p:sp>
+      <p:sp>
+        <p:nvSpPr>
+          <p:cNvPr id="9" name="Text 7"/>
+          <p:cNvSpPr txBox="1"/>
+          <p:nvPr/>
+        </p:nvSpPr>
+        <p:spPr>
+          <a:xfrm>
+            <a:off x="731520" y="3840480"/>
+            <a:ext cx="1664208" cy="1737360"/>
+          </a:xfrm>
+          <a:prstGeom prst="rect">
+            <a:avLst/>
+          </a:prstGeom>
+          <a:noFill/>
+          <a:ln/>
+        </p:spPr>
+        <p:txBody>
+          <a:bodyPr wrap="square" lIns="0" tIns="0" rIns="0" bIns="0" rtlCol="0" anchor="ctr"/>
+          <a:lstStyle/>
+          <a:p>
+            <a:pPr indent="0" marL="0">
+              <a:lnSpc>
+                <a:spcPct val="120000"/>
+              </a:lnSpc>
+              <a:buNone/>
+            </a:pPr>
+            <a:r>
+              <a:rPr lang="en-US" sz="1050" dirty="0">
+                <a:solidFill>
+                  <a:srgbClr val="C9CEE8"/>
+                </a:solidFill>
+                <a:latin typeface="Calibri" pitchFamily="34" charset="0"/>
+                <a:ea typeface="Calibri" pitchFamily="34" charset="-122"/>
+                <a:cs typeface="Calibri" pitchFamily="34" charset="-120"/>
+              </a:rPr>
+              <a:t>10–20 India founder interviews. Kill criteria set. Zero production code.</a:t>
+            </a:r>
+            <a:endParaRPr lang="en-US" sz="1050" dirty="0"/>
+          </a:p>
+        </p:txBody>
+      </p:sp>
+      <p:sp>
+        <p:nvSpPr>
+          <p:cNvPr id="10" name="Text 8"/>
+          <p:cNvSpPr txBox="1"/>
+          <p:nvPr/>
+        </p:nvSpPr>
+        <p:spPr>
+          <a:xfrm>
+            <a:off x="731520" y="5376672"/>
+            <a:ext cx="1664208" cy="274320"/>
+          </a:xfrm>
+          <a:prstGeom prst="rect">
+            <a:avLst/>
+          </a:prstGeom>
+          <a:noFill/>
+          <a:ln/>
+        </p:spPr>
+        <p:txBody>
+          <a:bodyPr wrap="square" lIns="0" tIns="0" rIns="0" bIns="0" rtlCol="0" anchor="ctr"/>
+          <a:lstStyle/>
+          <a:p>
+            <a:pPr indent="0" marL="0">
+              <a:buNone/>
+            </a:pPr>
+            <a:r>
+              <a:rPr lang="en-US" sz="900" b="1" spc="100" kern="0" dirty="0">
+                <a:solidFill>
+                  <a:srgbClr val="F96167"/>
+                </a:solidFill>
+                <a:latin typeface="Calibri" pitchFamily="34" charset="0"/>
+                <a:ea typeface="Calibri" pitchFamily="34" charset="-122"/>
+                <a:cs typeface="Calibri" pitchFamily="34" charset="-120"/>
+              </a:rPr>
+              <a:t>THIS RAISE</a:t>
+            </a:r>
+            <a:endParaRPr lang="en-US" sz="900" dirty="0"/>
+          </a:p>
+        </p:txBody>
+      </p:sp>
+      <p:sp>
+        <p:nvSpPr>
+          <p:cNvPr id="11" name="Text 9"/>
+          <p:cNvSpPr txBox="1"/>
+          <p:nvPr/>
+        </p:nvSpPr>
+        <p:spPr>
+          <a:xfrm>
+            <a:off x="2583180" y="3845052"/>
+            <a:ext cx="137160" cy="402336"/>
+          </a:xfrm>
+          <a:prstGeom prst="rect">
+            <a:avLst/>
+          </a:prstGeom>
+          <a:noFill/>
+          <a:ln/>
+        </p:spPr>
+        <p:txBody>
+          <a:bodyPr wrap="square" lIns="0" tIns="0" rIns="0" bIns="0" rtlCol="0" anchor="ctr"/>
+          <a:lstStyle/>
+          <a:p>
+            <a:pPr algn="ctr" indent="0" marL="0">
+              <a:buNone/>
+            </a:pPr>
+            <a:r>
+              <a:rPr lang="en-US" sz="1600" b="1" dirty="0">
+                <a:solidFill>
+                  <a:srgbClr val="6B76A8"/>
+                </a:solidFill>
+                <a:latin typeface="Calibri" pitchFamily="34" charset="0"/>
+                <a:ea typeface="Calibri" pitchFamily="34" charset="-122"/>
+                <a:cs typeface="Calibri" pitchFamily="34" charset="-120"/>
+              </a:rPr>
+              <a:t>→</a:t>
+            </a:r>
+            <a:endParaRPr lang="en-US" sz="1600" dirty="0"/>
+          </a:p>
+        </p:txBody>
+      </p:sp>
+      <p:sp>
+        <p:nvSpPr>
+          <p:cNvPr id="12" name="Shape 10"/>
+          <p:cNvSpPr/>
+          <p:nvPr/>
+        </p:nvSpPr>
+        <p:spPr>
+          <a:xfrm>
+            <a:off x="2724912" y="2331720"/>
+            <a:ext cx="2029968" cy="3429000"/>
+          </a:xfrm>
+          <a:prstGeom prst="roundRect">
+            <a:avLst>
+              <a:gd name="adj" fmla="val 4505"/>
+            </a:avLst>
+          </a:prstGeom>
+          <a:solidFill>
+            <a:srgbClr val="2F3C7E"/>
+          </a:solidFill>
+          <a:ln w="19050">
+            <a:solidFill>
+              <a:srgbClr val="F96167"/>
+            </a:solidFill>
+            <a:prstDash val="solid"/>
+          </a:ln>
+        </p:spPr>
+      </p:sp>
+      <p:sp>
+        <p:nvSpPr>
+          <p:cNvPr id="13" name="Text 11"/>
+          <p:cNvSpPr txBox="1"/>
+          <p:nvPr/>
+        </p:nvSpPr>
+        <p:spPr>
+          <a:xfrm>
+            <a:off x="2907792" y="2496312"/>
+            <a:ext cx="914400" cy="365760"/>
+          </a:xfrm>
+          <a:prstGeom prst="rect">
+            <a:avLst/>
+          </a:prstGeom>
+          <a:noFill/>
+          <a:ln/>
+        </p:spPr>
+        <p:txBody>
+          <a:bodyPr wrap="square" lIns="0" tIns="0" rIns="0" bIns="0" rtlCol="0" anchor="ctr"/>
+          <a:lstStyle/>
+          <a:p>
+            <a:pPr indent="0" marL="0">
+              <a:buNone/>
+            </a:pPr>
+            <a:r>
+              <a:rPr lang="en-US" sz="1500" b="1" dirty="0">
+                <a:solidFill>
+                  <a:srgbClr val="F96167"/>
+                </a:solidFill>
+                <a:latin typeface="Cambria" pitchFamily="34" charset="0"/>
+                <a:ea typeface="Cambria" pitchFamily="34" charset="-122"/>
+                <a:cs typeface="Cambria" pitchFamily="34" charset="-120"/>
+              </a:rPr>
+              <a:t>02</a:t>
+            </a:r>
+            <a:endParaRPr lang="en-US" sz="1500" dirty="0"/>
+          </a:p>
+        </p:txBody>
+      </p:sp>
+      <p:sp>
+        <p:nvSpPr>
+          <p:cNvPr id="14" name="Text 12"/>
+          <p:cNvSpPr txBox="1"/>
+          <p:nvPr/>
+        </p:nvSpPr>
+        <p:spPr>
+          <a:xfrm>
+            <a:off x="2907792" y="2880360"/>
+            <a:ext cx="1664208" cy="594360"/>
+          </a:xfrm>
+          <a:prstGeom prst="rect">
+            <a:avLst/>
+          </a:prstGeom>
+          <a:noFill/>
+          <a:ln/>
+        </p:spPr>
+        <p:txBody>
+          <a:bodyPr wrap="square" lIns="0" tIns="0" rIns="0" bIns="0" rtlCol="0" anchor="ctr"/>
+          <a:lstStyle/>
+          <a:p>
+            <a:pPr indent="0" marL="0">
+              <a:lnSpc>
+                <a:spcPct val="110000"/>
+              </a:lnSpc>
+              <a:buNone/>
+            </a:pPr>
+            <a:r>
+              <a:rPr lang="en-US" sz="1400" b="1" dirty="0">
+                <a:solidFill>
+                  <a:srgbClr val="FFFFFF"/>
+                </a:solidFill>
+                <a:latin typeface="Calibri" pitchFamily="34" charset="0"/>
+                <a:ea typeface="Calibri" pitchFamily="34" charset="-122"/>
+                <a:cs typeface="Calibri" pitchFamily="34" charset="-120"/>
+              </a:rPr>
+              <a:t>India MVP</a:t>
+            </a:r>
+            <a:endParaRPr lang="en-US" sz="1400" dirty="0"/>
+          </a:p>
+        </p:txBody>
+      </p:sp>
+      <p:sp>
+        <p:nvSpPr>
+          <p:cNvPr id="15" name="Text 13"/>
+          <p:cNvSpPr txBox="1"/>
+          <p:nvPr/>
+        </p:nvSpPr>
+        <p:spPr>
+          <a:xfrm>
+            <a:off x="2907792" y="3502152"/>
+            <a:ext cx="1664208" cy="274320"/>
+          </a:xfrm>
+          <a:prstGeom prst="rect">
+            <a:avLst/>
+          </a:prstGeom>
+          <a:noFill/>
+          <a:ln/>
+        </p:spPr>
+        <p:txBody>
+          <a:bodyPr wrap="square" lIns="0" tIns="0" rIns="0" bIns="0" rtlCol="0" anchor="ctr"/>
+          <a:lstStyle/>
+          <a:p>
+            <a:pPr indent="0" marL="0">
+              <a:buNone/>
+            </a:pPr>
+            <a:r>
+              <a:rPr lang="en-US" sz="1000" i="1" dirty="0">
+                <a:solidFill>
+                  <a:srgbClr val="FFD9DA"/>
+                </a:solidFill>
+                <a:latin typeface="Calibri" pitchFamily="34" charset="0"/>
+                <a:ea typeface="Calibri" pitchFamily="34" charset="-122"/>
+                <a:cs typeface="Calibri" pitchFamily="34" charset="-120"/>
+              </a:rPr>
+              <a:t>Nov 2026–Feb 2027</a:t>
+            </a:r>
+            <a:endParaRPr lang="en-US" sz="1000" dirty="0"/>
+          </a:p>
+        </p:txBody>
+      </p:sp>
+      <p:sp>
+        <p:nvSpPr>
+          <p:cNvPr id="16" name="Text 14"/>
+          <p:cNvSpPr txBox="1"/>
+          <p:nvPr/>
+        </p:nvSpPr>
+        <p:spPr>
+          <a:xfrm>
+            <a:off x="2907792" y="3840480"/>
+            <a:ext cx="1664208" cy="1737360"/>
+          </a:xfrm>
+          <a:prstGeom prst="rect">
+            <a:avLst/>
+          </a:prstGeom>
+          <a:noFill/>
+          <a:ln/>
+        </p:spPr>
+        <p:txBody>
+          <a:bodyPr wrap="square" lIns="0" tIns="0" rIns="0" bIns="0" rtlCol="0" anchor="ctr"/>
+          <a:lstStyle/>
+          <a:p>
+            <a:pPr indent="0" marL="0">
+              <a:lnSpc>
+                <a:spcPct val="120000"/>
+              </a:lnSpc>
+              <a:buNone/>
+            </a:pPr>
+            <a:r>
+              <a:rPr lang="en-US" sz="1050" dirty="0">
+                <a:solidFill>
+                  <a:srgbClr val="C9CEE8"/>
+                </a:solidFill>
+                <a:latin typeface="Calibri" pitchFamily="34" charset="0"/>
+                <a:ea typeface="Calibri" pitchFamily="34" charset="-122"/>
+                <a:cs typeface="Calibri" pitchFamily="34" charset="-120"/>
+              </a:rPr>
+              <a:t>3 core integrations live. 5–10 paying design-partner brands.</a:t>
+            </a:r>
+            <a:endParaRPr lang="en-US" sz="1050" dirty="0"/>
+          </a:p>
+        </p:txBody>
+      </p:sp>
+      <p:sp>
+        <p:nvSpPr>
+          <p:cNvPr id="17" name="Text 15"/>
+          <p:cNvSpPr txBox="1"/>
+          <p:nvPr/>
+        </p:nvSpPr>
+        <p:spPr>
+          <a:xfrm>
+            <a:off x="2907792" y="5376672"/>
+            <a:ext cx="1664208" cy="274320"/>
+          </a:xfrm>
+          <a:prstGeom prst="rect">
+            <a:avLst/>
+          </a:prstGeom>
+          <a:noFill/>
+          <a:ln/>
+        </p:spPr>
+        <p:txBody>
+          <a:bodyPr wrap="square" lIns="0" tIns="0" rIns="0" bIns="0" rtlCol="0" anchor="ctr"/>
+          <a:lstStyle/>
+          <a:p>
+            <a:pPr indent="0" marL="0">
+              <a:buNone/>
+            </a:pPr>
+            <a:r>
+              <a:rPr lang="en-US" sz="900" b="1" spc="100" kern="0" dirty="0">
+                <a:solidFill>
+                  <a:srgbClr val="F96167"/>
+                </a:solidFill>
+                <a:latin typeface="Calibri" pitchFamily="34" charset="0"/>
+                <a:ea typeface="Calibri" pitchFamily="34" charset="-122"/>
+                <a:cs typeface="Calibri" pitchFamily="34" charset="-120"/>
+              </a:rPr>
+              <a:t>THIS RAISE</a:t>
+            </a:r>
+            <a:endParaRPr lang="en-US" sz="900" dirty="0"/>
+          </a:p>
+        </p:txBody>
+      </p:sp>
+      <p:sp>
+        <p:nvSpPr>
+          <p:cNvPr id="18" name="Text 16"/>
+          <p:cNvSpPr txBox="1"/>
+          <p:nvPr/>
+        </p:nvSpPr>
+        <p:spPr>
+          <a:xfrm>
+            <a:off x="4759452" y="3845052"/>
+            <a:ext cx="137160" cy="402336"/>
+          </a:xfrm>
+          <a:prstGeom prst="rect">
+            <a:avLst/>
+          </a:prstGeom>
+          <a:noFill/>
+          <a:ln/>
+        </p:spPr>
+        <p:txBody>
+          <a:bodyPr wrap="square" lIns="0" tIns="0" rIns="0" bIns="0" rtlCol="0" anchor="ctr"/>
+          <a:lstStyle/>
+          <a:p>
+            <a:pPr algn="ctr" indent="0" marL="0">
+              <a:buNone/>
+            </a:pPr>
+            <a:r>
+              <a:rPr lang="en-US" sz="1600" b="1" dirty="0">
+                <a:solidFill>
+                  <a:srgbClr val="6B76A8"/>
+                </a:solidFill>
+                <a:latin typeface="Calibri" pitchFamily="34" charset="0"/>
+                <a:ea typeface="Calibri" pitchFamily="34" charset="-122"/>
+                <a:cs typeface="Calibri" pitchFamily="34" charset="-120"/>
+              </a:rPr>
+              <a:t>→</a:t>
+            </a:r>
+            <a:endParaRPr lang="en-US" sz="1600" dirty="0"/>
+          </a:p>
+        </p:txBody>
+      </p:sp>
+      <p:sp>
+        <p:nvSpPr>
+          <p:cNvPr id="19" name="Shape 17"/>
+          <p:cNvSpPr/>
+          <p:nvPr/>
+        </p:nvSpPr>
+        <p:spPr>
+          <a:xfrm>
+            <a:off x="4901184" y="2331720"/>
+            <a:ext cx="2029968" cy="3429000"/>
+          </a:xfrm>
+          <a:prstGeom prst="roundRect">
+            <a:avLst>
+              <a:gd name="adj" fmla="val 4505"/>
+            </a:avLst>
+          </a:prstGeom>
+          <a:solidFill>
+            <a:srgbClr val="222E5E"/>
+          </a:solidFill>
+          <a:ln/>
+        </p:spPr>
+      </p:sp>
+      <p:sp>
+        <p:nvSpPr>
+          <p:cNvPr id="20" name="Text 18"/>
+          <p:cNvSpPr txBox="1"/>
+          <p:nvPr/>
+        </p:nvSpPr>
+        <p:spPr>
+          <a:xfrm>
+            <a:off x="5084064" y="2496312"/>
+            <a:ext cx="914400" cy="365760"/>
+          </a:xfrm>
+          <a:prstGeom prst="rect">
+            <a:avLst/>
+          </a:prstGeom>
+          <a:noFill/>
+          <a:ln/>
+        </p:spPr>
+        <p:txBody>
+          <a:bodyPr wrap="square" lIns="0" tIns="0" rIns="0" bIns="0" rtlCol="0" anchor="ctr"/>
+          <a:lstStyle/>
+          <a:p>
+            <a:pPr indent="0" marL="0">
+              <a:buNone/>
+            </a:pPr>
+            <a:r>
+              <a:rPr lang="en-US" sz="1500" b="1" dirty="0">
+                <a:solidFill>
+                  <a:srgbClr val="4A5694"/>
+                </a:solidFill>
+                <a:latin typeface="Cambria" pitchFamily="34" charset="0"/>
+                <a:ea typeface="Cambria" pitchFamily="34" charset="-122"/>
+                <a:cs typeface="Cambria" pitchFamily="34" charset="-120"/>
+              </a:rPr>
+              <a:t>03</a:t>
+            </a:r>
+            <a:endParaRPr lang="en-US" sz="1500" dirty="0"/>
+          </a:p>
+        </p:txBody>
+      </p:sp>
+      <p:sp>
+        <p:nvSpPr>
+          <p:cNvPr id="21" name="Text 19"/>
+          <p:cNvSpPr txBox="1"/>
+          <p:nvPr/>
+        </p:nvSpPr>
+        <p:spPr>
+          <a:xfrm>
+            <a:off x="5084064" y="2880360"/>
+            <a:ext cx="1664208" cy="594360"/>
+          </a:xfrm>
+          <a:prstGeom prst="rect">
+            <a:avLst/>
+          </a:prstGeom>
+          <a:noFill/>
+          <a:ln/>
+        </p:spPr>
+        <p:txBody>
+          <a:bodyPr wrap="square" lIns="0" tIns="0" rIns="0" bIns="0" rtlCol="0" anchor="ctr"/>
+          <a:lstStyle/>
+          <a:p>
+            <a:pPr indent="0" marL="0">
+              <a:lnSpc>
+                <a:spcPct val="110000"/>
+              </a:lnSpc>
+              <a:buNone/>
+            </a:pPr>
+            <a:r>
+              <a:rPr lang="en-US" sz="1400" b="1" dirty="0">
+                <a:solidFill>
+                  <a:srgbClr val="FFFFFF"/>
+                </a:solidFill>
+                <a:latin typeface="Calibri" pitchFamily="34" charset="0"/>
+                <a:ea typeface="Calibri" pitchFamily="34" charset="-122"/>
+                <a:cs typeface="Calibri" pitchFamily="34" charset="-120"/>
+              </a:rPr>
+              <a:t>India Scale</a:t>
+            </a:r>
+            <a:endParaRPr lang="en-US" sz="1400" dirty="0"/>
+          </a:p>
+        </p:txBody>
+      </p:sp>
+      <p:sp>
+        <p:nvSpPr>
+          <p:cNvPr id="22" name="Text 20"/>
+          <p:cNvSpPr txBox="1"/>
+          <p:nvPr/>
+        </p:nvSpPr>
+        <p:spPr>
+          <a:xfrm>
+            <a:off x="5084064" y="3502152"/>
+            <a:ext cx="1664208" cy="274320"/>
+          </a:xfrm>
+          <a:prstGeom prst="rect">
+            <a:avLst/>
+          </a:prstGeom>
+          <a:noFill/>
+          <a:ln/>
+        </p:spPr>
+        <p:txBody>
+          <a:bodyPr wrap="square" lIns="0" tIns="0" rIns="0" bIns="0" rtlCol="0" anchor="ctr"/>
+          <a:lstStyle/>
+          <a:p>
+            <a:pPr indent="0" marL="0">
+              <a:buNone/>
+            </a:pPr>
+            <a:r>
+              <a:rPr lang="en-US" sz="1000" i="1" dirty="0">
+                <a:solidFill>
+                  <a:srgbClr val="9AA3C7"/>
+                </a:solidFill>
+                <a:latin typeface="Calibri" pitchFamily="34" charset="0"/>
+                <a:ea typeface="Calibri" pitchFamily="34" charset="-122"/>
+                <a:cs typeface="Calibri" pitchFamily="34" charset="-120"/>
+              </a:rPr>
+              <a:t>2027 H1</a:t>
+            </a:r>
+            <a:endParaRPr lang="en-US" sz="1000" dirty="0"/>
+          </a:p>
+        </p:txBody>
+      </p:sp>
+      <p:sp>
+        <p:nvSpPr>
+          <p:cNvPr id="23" name="Text 21"/>
+          <p:cNvSpPr txBox="1"/>
+          <p:nvPr/>
+        </p:nvSpPr>
+        <p:spPr>
+          <a:xfrm>
+            <a:off x="5084064" y="3840480"/>
+            <a:ext cx="1664208" cy="1737360"/>
+          </a:xfrm>
+          <a:prstGeom prst="rect">
+            <a:avLst/>
+          </a:prstGeom>
+          <a:noFill/>
+          <a:ln/>
+        </p:spPr>
+        <p:txBody>
+          <a:bodyPr wrap="square" lIns="0" tIns="0" rIns="0" bIns="0" rtlCol="0" anchor="ctr"/>
+          <a:lstStyle/>
+          <a:p>
+            <a:pPr indent="0" marL="0">
+              <a:lnSpc>
+                <a:spcPct val="120000"/>
+              </a:lnSpc>
+              <a:buNone/>
+            </a:pPr>
+            <a:r>
+              <a:rPr lang="en-US" sz="1050" dirty="0">
+                <a:solidFill>
+                  <a:srgbClr val="C9CEE8"/>
+                </a:solidFill>
+                <a:latin typeface="Calibri" pitchFamily="34" charset="0"/>
+                <a:ea typeface="Calibri" pitchFamily="34" charset="-122"/>
+                <a:cs typeface="Calibri" pitchFamily="34" charset="-120"/>
+              </a:rPr>
+              <a:t>Full feature set incl. AI copilot. 30+ paying brands. Unit economics proven.</a:t>
+            </a:r>
+            <a:endParaRPr lang="en-US" sz="1050" dirty="0"/>
+          </a:p>
+        </p:txBody>
+      </p:sp>
+      <p:sp>
+        <p:nvSpPr>
+          <p:cNvPr id="24" name="Text 22"/>
+          <p:cNvSpPr txBox="1"/>
+          <p:nvPr/>
+        </p:nvSpPr>
+        <p:spPr>
+          <a:xfrm>
+            <a:off x="6935724" y="3845052"/>
+            <a:ext cx="137160" cy="402336"/>
+          </a:xfrm>
+          <a:prstGeom prst="rect">
+            <a:avLst/>
+          </a:prstGeom>
+          <a:noFill/>
+          <a:ln/>
+        </p:spPr>
+        <p:txBody>
+          <a:bodyPr wrap="square" lIns="0" tIns="0" rIns="0" bIns="0" rtlCol="0" anchor="ctr"/>
+          <a:lstStyle/>
+          <a:p>
+            <a:pPr algn="ctr" indent="0" marL="0">
+              <a:buNone/>
+            </a:pPr>
+            <a:r>
+              <a:rPr lang="en-US" sz="1600" b="1" dirty="0">
+                <a:solidFill>
+                  <a:srgbClr val="6B76A8"/>
+                </a:solidFill>
+                <a:latin typeface="Calibri" pitchFamily="34" charset="0"/>
+                <a:ea typeface="Calibri" pitchFamily="34" charset="-122"/>
+                <a:cs typeface="Calibri" pitchFamily="34" charset="-120"/>
+              </a:rPr>
+              <a:t>→</a:t>
+            </a:r>
+            <a:endParaRPr lang="en-US" sz="1600" dirty="0"/>
+          </a:p>
+        </p:txBody>
+      </p:sp>
+      <p:sp>
+        <p:nvSpPr>
+          <p:cNvPr id="25" name="Shape 23"/>
+          <p:cNvSpPr/>
+          <p:nvPr/>
+        </p:nvSpPr>
+        <p:spPr>
+          <a:xfrm>
+            <a:off x="7077456" y="2331720"/>
+            <a:ext cx="2029968" cy="3429000"/>
+          </a:xfrm>
+          <a:prstGeom prst="roundRect">
+            <a:avLst>
+              <a:gd name="adj" fmla="val 4505"/>
+            </a:avLst>
+          </a:prstGeom>
+          <a:solidFill>
+            <a:srgbClr val="222E5E"/>
+          </a:solidFill>
+          <a:ln/>
+        </p:spPr>
+      </p:sp>
+      <p:sp>
+        <p:nvSpPr>
+          <p:cNvPr id="26" name="Text 24"/>
+          <p:cNvSpPr txBox="1"/>
+          <p:nvPr/>
+        </p:nvSpPr>
+        <p:spPr>
+          <a:xfrm>
+            <a:off x="7260336" y="2496312"/>
+            <a:ext cx="914400" cy="365760"/>
+          </a:xfrm>
+          <a:prstGeom prst="rect">
+            <a:avLst/>
+          </a:prstGeom>
+          <a:noFill/>
+          <a:ln/>
+        </p:spPr>
+        <p:txBody>
+          <a:bodyPr wrap="square" lIns="0" tIns="0" rIns="0" bIns="0" rtlCol="0" anchor="ctr"/>
+          <a:lstStyle/>
+          <a:p>
+            <a:pPr indent="0" marL="0">
+              <a:buNone/>
+            </a:pPr>
+            <a:r>
+              <a:rPr lang="en-US" sz="1500" b="1" dirty="0">
+                <a:solidFill>
+                  <a:srgbClr val="4A5694"/>
+                </a:solidFill>
+                <a:latin typeface="Cambria" pitchFamily="34" charset="0"/>
+                <a:ea typeface="Cambria" pitchFamily="34" charset="-122"/>
+                <a:cs typeface="Cambria" pitchFamily="34" charset="-120"/>
+              </a:rPr>
+              <a:t>04</a:t>
+            </a:r>
+            <a:endParaRPr lang="en-US" sz="1500" dirty="0"/>
+          </a:p>
+        </p:txBody>
+      </p:sp>
+      <p:sp>
+        <p:nvSpPr>
+          <p:cNvPr id="27" name="Text 25"/>
+          <p:cNvSpPr txBox="1"/>
+          <p:nvPr/>
+        </p:nvSpPr>
+        <p:spPr>
+          <a:xfrm>
+            <a:off x="7260336" y="2880360"/>
+            <a:ext cx="1664208" cy="594360"/>
+          </a:xfrm>
+          <a:prstGeom prst="rect">
+            <a:avLst/>
+          </a:prstGeom>
+          <a:noFill/>
+          <a:ln/>
+        </p:spPr>
+        <p:txBody>
+          <a:bodyPr wrap="square" lIns="0" tIns="0" rIns="0" bIns="0" rtlCol="0" anchor="ctr"/>
+          <a:lstStyle/>
+          <a:p>
+            <a:pPr indent="0" marL="0">
+              <a:lnSpc>
+                <a:spcPct val="110000"/>
+              </a:lnSpc>
+              <a:buNone/>
+            </a:pPr>
+            <a:r>
+              <a:rPr lang="en-US" sz="1400" b="1" dirty="0">
+                <a:solidFill>
+                  <a:srgbClr val="FFFFFF"/>
+                </a:solidFill>
+                <a:latin typeface="Calibri" pitchFamily="34" charset="0"/>
+                <a:ea typeface="Calibri" pitchFamily="34" charset="-122"/>
+                <a:cs typeface="Calibri" pitchFamily="34" charset="-120"/>
+              </a:rPr>
+              <a:t>1st Adjacent Market</a:t>
+            </a:r>
+            <a:endParaRPr lang="en-US" sz="1400" dirty="0"/>
+          </a:p>
+        </p:txBody>
+      </p:sp>
+      <p:sp>
+        <p:nvSpPr>
+          <p:cNvPr id="28" name="Text 26"/>
+          <p:cNvSpPr txBox="1"/>
+          <p:nvPr/>
+        </p:nvSpPr>
+        <p:spPr>
+          <a:xfrm>
+            <a:off x="7260336" y="3502152"/>
+            <a:ext cx="1664208" cy="274320"/>
+          </a:xfrm>
+          <a:prstGeom prst="rect">
+            <a:avLst/>
+          </a:prstGeom>
+          <a:noFill/>
+          <a:ln/>
+        </p:spPr>
+        <p:txBody>
+          <a:bodyPr wrap="square" lIns="0" tIns="0" rIns="0" bIns="0" rtlCol="0" anchor="ctr"/>
+          <a:lstStyle/>
+          <a:p>
+            <a:pPr indent="0" marL="0">
+              <a:buNone/>
+            </a:pPr>
+            <a:r>
+              <a:rPr lang="en-US" sz="1000" i="1" dirty="0">
+                <a:solidFill>
+                  <a:srgbClr val="9AA3C7"/>
+                </a:solidFill>
+                <a:latin typeface="Calibri" pitchFamily="34" charset="0"/>
+                <a:ea typeface="Calibri" pitchFamily="34" charset="-122"/>
+                <a:cs typeface="Calibri" pitchFamily="34" charset="-120"/>
+              </a:rPr>
+              <a:t>2027 H2</a:t>
+            </a:r>
+            <a:endParaRPr lang="en-US" sz="1000" dirty="0"/>
+          </a:p>
+        </p:txBody>
+      </p:sp>
+      <p:sp>
+        <p:nvSpPr>
+          <p:cNvPr id="29" name="Text 27"/>
+          <p:cNvSpPr txBox="1"/>
+          <p:nvPr/>
+        </p:nvSpPr>
+        <p:spPr>
+          <a:xfrm>
+            <a:off x="7260336" y="3840480"/>
+            <a:ext cx="1664208" cy="1737360"/>
+          </a:xfrm>
+          <a:prstGeom prst="rect">
+            <a:avLst/>
+          </a:prstGeom>
+          <a:noFill/>
+          <a:ln/>
+        </p:spPr>
+        <p:txBody>
+          <a:bodyPr wrap="square" lIns="0" tIns="0" rIns="0" bIns="0" rtlCol="0" anchor="ctr"/>
+          <a:lstStyle/>
+          <a:p>
+            <a:pPr indent="0" marL="0">
+              <a:lnSpc>
+                <a:spcPct val="120000"/>
+              </a:lnSpc>
+              <a:buNone/>
+            </a:pPr>
+            <a:r>
+              <a:rPr lang="en-US" sz="1050" dirty="0">
+                <a:solidFill>
+                  <a:srgbClr val="C9CEE8"/>
+                </a:solidFill>
+                <a:latin typeface="Calibri" pitchFamily="34" charset="0"/>
+                <a:ea typeface="Calibri" pitchFamily="34" charset="-122"/>
+                <a:cs typeface="Calibri" pitchFamily="34" charset="-120"/>
+              </a:rPr>
+              <a:t>Test the same payment-ecosystem-gap thesis in one new market (SEA or LatAm).</a:t>
+            </a:r>
+            <a:endParaRPr lang="en-US" sz="1050" dirty="0"/>
+          </a:p>
+        </p:txBody>
+      </p:sp>
+      <p:sp>
+        <p:nvSpPr>
+          <p:cNvPr id="30" name="Text 28"/>
+          <p:cNvSpPr txBox="1"/>
+          <p:nvPr/>
+        </p:nvSpPr>
+        <p:spPr>
+          <a:xfrm>
+            <a:off x="9111996" y="3845052"/>
+            <a:ext cx="137160" cy="402336"/>
+          </a:xfrm>
+          <a:prstGeom prst="rect">
+            <a:avLst/>
+          </a:prstGeom>
+          <a:noFill/>
+          <a:ln/>
+        </p:spPr>
+        <p:txBody>
+          <a:bodyPr wrap="square" lIns="0" tIns="0" rIns="0" bIns="0" rtlCol="0" anchor="ctr"/>
+          <a:lstStyle/>
+          <a:p>
+            <a:pPr algn="ctr" indent="0" marL="0">
+              <a:buNone/>
+            </a:pPr>
+            <a:r>
+              <a:rPr lang="en-US" sz="1600" b="1" dirty="0">
+                <a:solidFill>
+                  <a:srgbClr val="6B76A8"/>
+                </a:solidFill>
+                <a:latin typeface="Calibri" pitchFamily="34" charset="0"/>
+                <a:ea typeface="Calibri" pitchFamily="34" charset="-122"/>
+                <a:cs typeface="Calibri" pitchFamily="34" charset="-120"/>
+              </a:rPr>
+              <a:t>→</a:t>
+            </a:r>
+            <a:endParaRPr lang="en-US" sz="1600" dirty="0"/>
+          </a:p>
+        </p:txBody>
+      </p:sp>
+      <p:sp>
+        <p:nvSpPr>
+          <p:cNvPr id="31" name="Shape 29"/>
+          <p:cNvSpPr/>
+          <p:nvPr/>
+        </p:nvSpPr>
+        <p:spPr>
+          <a:xfrm>
+            <a:off x="9253728" y="2331720"/>
+            <a:ext cx="2029968" cy="3429000"/>
+          </a:xfrm>
+          <a:prstGeom prst="roundRect">
+            <a:avLst>
+              <a:gd name="adj" fmla="val 4505"/>
+            </a:avLst>
+          </a:prstGeom>
+          <a:solidFill>
+            <a:srgbClr val="222E5E"/>
+          </a:solidFill>
+          <a:ln/>
+        </p:spPr>
+      </p:sp>
+      <p:sp>
+        <p:nvSpPr>
+          <p:cNvPr id="32" name="Text 30"/>
+          <p:cNvSpPr txBox="1"/>
+          <p:nvPr/>
+        </p:nvSpPr>
+        <p:spPr>
+          <a:xfrm>
+            <a:off x="9436608" y="2496312"/>
+            <a:ext cx="914400" cy="365760"/>
+          </a:xfrm>
+          <a:prstGeom prst="rect">
+            <a:avLst/>
+          </a:prstGeom>
+          <a:noFill/>
+          <a:ln/>
+        </p:spPr>
+        <p:txBody>
+          <a:bodyPr wrap="square" lIns="0" tIns="0" rIns="0" bIns="0" rtlCol="0" anchor="ctr"/>
+          <a:lstStyle/>
+          <a:p>
+            <a:pPr indent="0" marL="0">
+              <a:buNone/>
+            </a:pPr>
+            <a:r>
+              <a:rPr lang="en-US" sz="1500" b="1" dirty="0">
+                <a:solidFill>
+                  <a:srgbClr val="4A5694"/>
+                </a:solidFill>
+                <a:latin typeface="Cambria" pitchFamily="34" charset="0"/>
+                <a:ea typeface="Cambria" pitchFamily="34" charset="-122"/>
+                <a:cs typeface="Cambria" pitchFamily="34" charset="-120"/>
+              </a:rPr>
+              <a:t>05</a:t>
+            </a:r>
+            <a:endParaRPr lang="en-US" sz="1500" dirty="0"/>
+          </a:p>
+        </p:txBody>
+      </p:sp>
+      <p:sp>
+        <p:nvSpPr>
+          <p:cNvPr id="33" name="Text 31"/>
+          <p:cNvSpPr txBox="1"/>
+          <p:nvPr/>
+        </p:nvSpPr>
+        <p:spPr>
+          <a:xfrm>
+            <a:off x="9436608" y="2880360"/>
+            <a:ext cx="1664208" cy="594360"/>
+          </a:xfrm>
+          <a:prstGeom prst="rect">
+            <a:avLst/>
+          </a:prstGeom>
+          <a:noFill/>
+          <a:ln/>
+        </p:spPr>
+        <p:txBody>
+          <a:bodyPr wrap="square" lIns="0" tIns="0" rIns="0" bIns="0" rtlCol="0" anchor="ctr"/>
+          <a:lstStyle/>
+          <a:p>
+            <a:pPr indent="0" marL="0">
+              <a:lnSpc>
+                <a:spcPct val="110000"/>
+              </a:lnSpc>
+              <a:buNone/>
+            </a:pPr>
+            <a:r>
+              <a:rPr lang="en-US" sz="1400" b="1" dirty="0">
+                <a:solidFill>
+                  <a:srgbClr val="FFFFFF"/>
+                </a:solidFill>
+                <a:latin typeface="Calibri" pitchFamily="34" charset="0"/>
+                <a:ea typeface="Calibri" pitchFamily="34" charset="-122"/>
+                <a:cs typeface="Calibri" pitchFamily="34" charset="-120"/>
+              </a:rPr>
+              <a:t>Multi-Market</a:t>
+            </a:r>
+            <a:endParaRPr lang="en-US" sz="1400" dirty="0"/>
+          </a:p>
+        </p:txBody>
+      </p:sp>
+      <p:sp>
+        <p:nvSpPr>
+          <p:cNvPr id="34" name="Text 32"/>
+          <p:cNvSpPr txBox="1"/>
+          <p:nvPr/>
+        </p:nvSpPr>
+        <p:spPr>
+          <a:xfrm>
+            <a:off x="9436608" y="3502152"/>
+            <a:ext cx="1664208" cy="274320"/>
+          </a:xfrm>
+          <a:prstGeom prst="rect">
+            <a:avLst/>
+          </a:prstGeom>
+          <a:noFill/>
+          <a:ln/>
+        </p:spPr>
+        <p:txBody>
+          <a:bodyPr wrap="square" lIns="0" tIns="0" rIns="0" bIns="0" rtlCol="0" anchor="ctr"/>
+          <a:lstStyle/>
+          <a:p>
+            <a:pPr indent="0" marL="0">
+              <a:buNone/>
+            </a:pPr>
+            <a:r>
+              <a:rPr lang="en-US" sz="1000" i="1" dirty="0">
+                <a:solidFill>
+                  <a:srgbClr val="9AA3C7"/>
+                </a:solidFill>
+                <a:latin typeface="Calibri" pitchFamily="34" charset="0"/>
+                <a:ea typeface="Calibri" pitchFamily="34" charset="-122"/>
+                <a:cs typeface="Calibri" pitchFamily="34" charset="-120"/>
+              </a:rPr>
+              <a:t>2028+</a:t>
+            </a:r>
+            <a:endParaRPr lang="en-US" sz="1000" dirty="0"/>
+          </a:p>
+        </p:txBody>
+      </p:sp>
+      <p:sp>
+        <p:nvSpPr>
+          <p:cNvPr id="35" name="Text 33"/>
+          <p:cNvSpPr txBox="1"/>
+          <p:nvPr/>
+        </p:nvSpPr>
+        <p:spPr>
+          <a:xfrm>
+            <a:off x="9436608" y="3840480"/>
+            <a:ext cx="1664208" cy="1737360"/>
+          </a:xfrm>
+          <a:prstGeom prst="rect">
+            <a:avLst/>
+          </a:prstGeom>
+          <a:noFill/>
+          <a:ln/>
+        </p:spPr>
+        <p:txBody>
+          <a:bodyPr wrap="square" lIns="0" tIns="0" rIns="0" bIns="0" rtlCol="0" anchor="ctr"/>
+          <a:lstStyle/>
+          <a:p>
+            <a:pPr indent="0" marL="0">
+              <a:lnSpc>
+                <a:spcPct val="120000"/>
+              </a:lnSpc>
+              <a:buNone/>
+            </a:pPr>
+            <a:r>
+              <a:rPr lang="en-US" sz="1050" dirty="0">
+                <a:solidFill>
+                  <a:srgbClr val="C9CEE8"/>
+                </a:solidFill>
+                <a:latin typeface="Calibri" pitchFamily="34" charset="0"/>
+                <a:ea typeface="Calibri" pitchFamily="34" charset="-122"/>
+                <a:cs typeface="Calibri" pitchFamily="34" charset="-120"/>
+              </a:rPr>
+              <a:t>Repeat the proven playbook market-by-market. Global positioning, now earned.</a:t>
+            </a:r>
+            <a:endParaRPr lang="en-US" sz="1050" dirty="0"/>
+          </a:p>
+        </p:txBody>
+      </p:sp>
+      <p:sp>
+        <p:nvSpPr>
+          <p:cNvPr id="36" name="Text 34"/>
+          <p:cNvSpPr txBox="1"/>
+          <p:nvPr/>
+        </p:nvSpPr>
+        <p:spPr>
+          <a:xfrm>
+            <a:off x="548640" y="5989320"/>
+            <a:ext cx="10881360" cy="365760"/>
+          </a:xfrm>
+          <a:prstGeom prst="rect">
+            <a:avLst/>
+          </a:prstGeom>
+          <a:noFill/>
+          <a:ln/>
+        </p:spPr>
+        <p:txBody>
+          <a:bodyPr wrap="square" lIns="0" tIns="0" rIns="0" bIns="0" rtlCol="0" anchor="ctr"/>
+          <a:lstStyle/>
+          <a:p>
+            <a:pPr indent="0" marL="0">
+              <a:buNone/>
+            </a:pPr>
+            <a:r>
+              <a:rPr lang="en-US" sz="1100" i="1" dirty="0">
+                <a:solidFill>
+                  <a:srgbClr val="9AA3C7"/>
+                </a:solidFill>
+                <a:latin typeface="Calibri" pitchFamily="34" charset="0"/>
+                <a:ea typeface="Calibri" pitchFamily="34" charset="-122"/>
+                <a:cs typeface="Calibri" pitchFamily="34" charset="-120"/>
+              </a:rPr>
+              <a:t>Phases 01–02 (coral outline) are what this pre-seed round funds. Phases 03–05 are the vision this validates a path toward — not asked for today.</a:t>
+            </a:r>
+            <a:endParaRPr lang="en-US" sz="1100" dirty="0"/>
+          </a:p>
+        </p:txBody>
+      </p:sp>
+      <p:sp>
+        <p:nvSpPr>
+          <p:cNvPr id="37" name="Text 35"/>
+          <p:cNvSpPr txBox="1"/>
+          <p:nvPr/>
+        </p:nvSpPr>
+        <p:spPr>
+          <a:xfrm>
+            <a:off x="548640" y="6492240"/>
+            <a:ext cx="4572000" cy="274320"/>
+          </a:xfrm>
+          <a:prstGeom prst="rect">
+            <a:avLst/>
+          </a:prstGeom>
+          <a:noFill/>
+          <a:ln/>
+        </p:spPr>
+        <p:txBody>
+          <a:bodyPr wrap="square" lIns="0" tIns="0" rIns="0" bIns="0" rtlCol="0" anchor="ctr"/>
+          <a:lstStyle/>
+          <a:p>
+            <a:pPr indent="0" marL="0">
+              <a:buNone/>
+            </a:pPr>
+            <a:r>
+              <a:rPr lang="en-US" sz="1000" spc="100" kern="0" dirty="0">
+                <a:solidFill>
+                  <a:srgbClr val="9AA3C7"/>
+                </a:solidFill>
+                <a:latin typeface="Calibri" pitchFamily="34" charset="0"/>
+                <a:ea typeface="Calibri" pitchFamily="34" charset="-122"/>
+                <a:cs typeface="Calibri" pitchFamily="34" charset="-120"/>
+              </a:rPr>
+              <a:t>ECOMMERCE HUB  ·  PRE-SEED</a:t>
+            </a:r>
+            <a:endParaRPr lang="en-US" sz="1000" dirty="0"/>
+          </a:p>
+        </p:txBody>
+      </p:sp>
+      <p:sp>
+        <p:nvSpPr>
+          <p:cNvPr id="38" name="Text 36"/>
+          <p:cNvSpPr txBox="1"/>
+          <p:nvPr/>
+        </p:nvSpPr>
+        <p:spPr>
+          <a:xfrm>
+            <a:off x="11475720" y="6492240"/>
+            <a:ext cx="548640" cy="274320"/>
+          </a:xfrm>
+          <a:prstGeom prst="rect">
+            <a:avLst/>
+          </a:prstGeom>
+          <a:noFill/>
+          <a:ln/>
+        </p:spPr>
+        <p:txBody>
+          <a:bodyPr wrap="square" lIns="0" tIns="0" rIns="0" bIns="0" rtlCol="0" anchor="ctr"/>
+          <a:lstStyle/>
+          <a:p>
+            <a:pPr algn="r" indent="0" marL="0">
+              <a:buNone/>
+            </a:pPr>
+            <a:r>
+              <a:rPr lang="en-US" sz="1000" dirty="0">
+                <a:solidFill>
+                  <a:srgbClr val="9AA3C7"/>
+                </a:solidFill>
+                <a:latin typeface="Calibri" pitchFamily="34" charset="0"/>
+                <a:ea typeface="Calibri" pitchFamily="34" charset="-122"/>
+                <a:cs typeface="Calibri" pitchFamily="34" charset="-120"/>
+              </a:rPr>
+              <a:t>10</a:t>
+            </a:r>
+            <a:endParaRPr lang="en-US" sz="1000" dirty="0"/>
+          </a:p>
+        </p:txBody>
+      </p:sp>
+    </p:spTree>
+  </p:cSld>
+  <p:clrMapOvr>
+    <a:masterClrMapping/>
+  </p:clrMapOvr>
+</p:sld>
+</file>
+
+<file path=ppt/slides/slide11.xml><?xml version="1.0" encoding="utf-8"?>
+<p:sld xmlns:a="http://schemas.openxmlformats.org/drawingml/2006/main" xmlns:r="http://schemas.openxmlformats.org/officeDocument/2006/relationships" xmlns:p="http://schemas.openxmlformats.org/presentationml/2006/main">
+  <p:cSld name="Slide 11">
+    <p:bg>
+      <p:bgPr>
+        <a:solidFill>
           <a:srgbClr val="FFFFFF"/>
         </a:solidFill>
       </p:bgPr>
@@ -3038,7 +4816,7 @@
                 <a:ea typeface="Calibri" pitchFamily="34" charset="-122"/>
                 <a:cs typeface="Calibri" pitchFamily="34" charset="-120"/>
               </a:rPr>
-              <a:t>10</a:t>
+              <a:t>11</a:t>
             </a:r>
             <a:endParaRPr lang="en-US" sz="1000" dirty="0"/>
           </a:p>
@@ -3052,9 +4830,9 @@
 </p:sld>
 </file>
 
-<file path=ppt/slides/slide11.xml><?xml version="1.0" encoding="utf-8"?>
+<file path=ppt/slides/slide12.xml><?xml version="1.0" encoding="utf-8"?>
 <p:sld xmlns:a="http://schemas.openxmlformats.org/drawingml/2006/main" xmlns:r="http://schemas.openxmlformats.org/officeDocument/2006/relationships" xmlns:p="http://schemas.openxmlformats.org/presentationml/2006/main">
-  <p:cSld name="Slide 11">
+  <p:cSld name="Slide 12">
     <p:bg>
       <p:bgPr>
         <a:solidFill>
@@ -3808,7 +5586,7 @@
                 <a:ea typeface="Calibri" pitchFamily="34" charset="-122"/>
                 <a:cs typeface="Calibri" pitchFamily="34" charset="-120"/>
               </a:rPr>
-              <a:t>11</a:t>
+              <a:t>12</a:t>
             </a:r>
             <a:endParaRPr lang="en-US" sz="1000" dirty="0"/>
           </a:p>
@@ -3822,9 +5600,9 @@
 </p:sld>
 </file>
 
-<file path=ppt/slides/slide12.xml><?xml version="1.0" encoding="utf-8"?>
+<file path=ppt/slides/slide13.xml><?xml version="1.0" encoding="utf-8"?>
 <p:sld xmlns:a="http://schemas.openxmlformats.org/drawingml/2006/main" xmlns:r="http://schemas.openxmlformats.org/officeDocument/2006/relationships" xmlns:p="http://schemas.openxmlformats.org/presentationml/2006/main">
-  <p:cSld name="Slide 12">
+  <p:cSld name="Slide 13">
     <p:bg>
       <p:bgPr>
         <a:solidFill>
@@ -4385,7 +6163,7 @@
                 <a:ea typeface="Calibri" pitchFamily="34" charset="-122"/>
                 <a:cs typeface="Calibri" pitchFamily="34" charset="-120"/>
               </a:rPr>
-              <a:t>12</a:t>
+              <a:t>13</a:t>
             </a:r>
             <a:endParaRPr lang="en-US" sz="1000" dirty="0"/>
           </a:p>
@@ -4399,9 +6177,9 @@
 </p:sld>
 </file>
 
-<file path=ppt/slides/slide13.xml><?xml version="1.0" encoding="utf-8"?>
+<file path=ppt/slides/slide14.xml><?xml version="1.0" encoding="utf-8"?>
 <p:sld xmlns:a="http://schemas.openxmlformats.org/drawingml/2006/main" xmlns:r="http://schemas.openxmlformats.org/officeDocument/2006/relationships" xmlns:p="http://schemas.openxmlformats.org/presentationml/2006/main">
-  <p:cSld name="Slide 13">
+  <p:cSld name="Slide 14">
     <p:bg>
       <p:bgPr>
         <a:solidFill>
@@ -5104,7 +6882,7 @@
                 <a:ea typeface="Calibri" pitchFamily="34" charset="-122"/>
                 <a:cs typeface="Calibri" pitchFamily="34" charset="-120"/>
               </a:rPr>
-              <a:t>13</a:t>
+              <a:t>14</a:t>
             </a:r>
             <a:endParaRPr lang="en-US" sz="1000" dirty="0"/>
           </a:p>
@@ -8353,7 +10131,7 @@
                 <a:ea typeface="Cambria" pitchFamily="34" charset="-122"/>
                 <a:cs typeface="Cambria" pitchFamily="34" charset="-120"/>
               </a:rPr>
-              <a:t>A fast-growing market, with software spend nobody's captured yet</a:t>
+              <a:t>India today. An $8.5 trillion category to grow into.</a:t>
             </a:r>
             <a:endParaRPr lang="en-US" sz="3000" dirty="0"/>
           </a:p>
@@ -8367,12 +10145,12 @@
         </p:nvSpPr>
         <p:spPr>
           <a:xfrm>
-            <a:off x="548640" y="1783080"/>
-            <a:ext cx="3474720" cy="1554480"/>
+            <a:off x="548640" y="1645920"/>
+            <a:ext cx="3474720" cy="1051560"/>
           </a:xfrm>
           <a:prstGeom prst="roundRect">
             <a:avLst>
-              <a:gd name="adj" fmla="val 5882"/>
+              <a:gd name="adj" fmla="val 8696"/>
             </a:avLst>
           </a:prstGeom>
           <a:solidFill>
@@ -8394,24 +10172,24 @@
         </p:nvSpPr>
         <p:spPr>
           <a:xfrm>
-            <a:off x="777240" y="1920240"/>
-            <a:ext cx="3017520" cy="685800"/>
-          </a:xfrm>
-          <a:prstGeom prst="rect">
-            <a:avLst/>
-          </a:prstGeom>
-          <a:noFill/>
-          <a:ln/>
-        </p:spPr>
-        <p:txBody>
-          <a:bodyPr wrap="square" lIns="0" tIns="0" rIns="0" bIns="0" rtlCol="0" anchor="ctr"/>
-          <a:lstStyle/>
-          <a:p>
-            <a:pPr indent="0" marL="0">
-              <a:buNone/>
-            </a:pPr>
-            <a:r>
-              <a:rPr lang="en-US" sz="3400" b="1" dirty="0">
+            <a:off x="777240" y="1719072"/>
+            <a:ext cx="3017520" cy="502920"/>
+          </a:xfrm>
+          <a:prstGeom prst="rect">
+            <a:avLst/>
+          </a:prstGeom>
+          <a:noFill/>
+          <a:ln/>
+        </p:spPr>
+        <p:txBody>
+          <a:bodyPr wrap="square" lIns="0" tIns="0" rIns="0" bIns="0" rtlCol="0" anchor="ctr"/>
+          <a:lstStyle/>
+          <a:p>
+            <a:pPr indent="0" marL="0">
+              <a:buNone/>
+            </a:pPr>
+            <a:r>
+              <a:rPr lang="en-US" sz="2600" b="1" dirty="0">
                 <a:solidFill>
                   <a:srgbClr val="2F3C7E"/>
                 </a:solidFill>
@@ -8421,7 +10199,7 @@
               </a:rPr>
               <a:t>$108.76B</a:t>
             </a:r>
-            <a:endParaRPr lang="en-US" sz="3400" dirty="0"/>
+            <a:endParaRPr lang="en-US" sz="2600" dirty="0"/>
           </a:p>
         </p:txBody>
       </p:sp>
@@ -8433,27 +10211,24 @@
         </p:nvSpPr>
         <p:spPr>
           <a:xfrm>
-            <a:off x="777240" y="2606040"/>
-            <a:ext cx="3017520" cy="640080"/>
-          </a:xfrm>
-          <a:prstGeom prst="rect">
-            <a:avLst/>
-          </a:prstGeom>
-          <a:noFill/>
-          <a:ln/>
-        </p:spPr>
-        <p:txBody>
-          <a:bodyPr wrap="square" lIns="0" tIns="0" rIns="0" bIns="0" rtlCol="0" anchor="ctr"/>
-          <a:lstStyle/>
-          <a:p>
-            <a:pPr indent="0" marL="0">
-              <a:lnSpc>
-                <a:spcPct val="120000"/>
-              </a:lnSpc>
-              <a:buNone/>
-            </a:pPr>
-            <a:r>
-              <a:rPr lang="en-US" sz="1150" dirty="0">
+            <a:off x="777240" y="2240280"/>
+            <a:ext cx="3017520" cy="365760"/>
+          </a:xfrm>
+          <a:prstGeom prst="rect">
+            <a:avLst/>
+          </a:prstGeom>
+          <a:noFill/>
+          <a:ln/>
+        </p:spPr>
+        <p:txBody>
+          <a:bodyPr wrap="square" lIns="0" tIns="0" rIns="0" bIns="0" rtlCol="0" anchor="ctr"/>
+          <a:lstStyle/>
+          <a:p>
+            <a:pPr indent="0" marL="0">
+              <a:buNone/>
+            </a:pPr>
+            <a:r>
+              <a:rPr lang="en-US" sz="1100" dirty="0">
                 <a:solidFill>
                   <a:srgbClr val="6B7280"/>
                 </a:solidFill>
@@ -8461,9 +10236,9 @@
                 <a:ea typeface="Calibri" pitchFamily="34" charset="-122"/>
                 <a:cs typeface="Calibri" pitchFamily="34" charset="-120"/>
               </a:rPr>
-              <a:t>India D2C e-commerce market, 2026</a:t>
-            </a:r>
-            <a:endParaRPr lang="en-US" sz="1150" dirty="0"/>
+              <a:t>India D2C market, 2026</a:t>
+            </a:r>
+            <a:endParaRPr lang="en-US" sz="1100" dirty="0"/>
           </a:p>
         </p:txBody>
       </p:sp>
@@ -8475,12 +10250,12 @@
         </p:nvSpPr>
         <p:spPr>
           <a:xfrm>
-            <a:off x="4251960" y="1783080"/>
-            <a:ext cx="3474720" cy="1554480"/>
+            <a:off x="4251960" y="1645920"/>
+            <a:ext cx="3474720" cy="1051560"/>
           </a:xfrm>
           <a:prstGeom prst="roundRect">
             <a:avLst>
-              <a:gd name="adj" fmla="val 5882"/>
+              <a:gd name="adj" fmla="val 8696"/>
             </a:avLst>
           </a:prstGeom>
           <a:solidFill>
@@ -8502,24 +10277,24 @@
         </p:nvSpPr>
         <p:spPr>
           <a:xfrm>
-            <a:off x="4480560" y="1920240"/>
-            <a:ext cx="3017520" cy="685800"/>
-          </a:xfrm>
-          <a:prstGeom prst="rect">
-            <a:avLst/>
-          </a:prstGeom>
-          <a:noFill/>
-          <a:ln/>
-        </p:spPr>
-        <p:txBody>
-          <a:bodyPr wrap="square" lIns="0" tIns="0" rIns="0" bIns="0" rtlCol="0" anchor="ctr"/>
-          <a:lstStyle/>
-          <a:p>
-            <a:pPr indent="0" marL="0">
-              <a:buNone/>
-            </a:pPr>
-            <a:r>
-              <a:rPr lang="en-US" sz="3400" b="1" dirty="0">
+            <a:off x="4480560" y="1719072"/>
+            <a:ext cx="3017520" cy="502920"/>
+          </a:xfrm>
+          <a:prstGeom prst="rect">
+            <a:avLst/>
+          </a:prstGeom>
+          <a:noFill/>
+          <a:ln/>
+        </p:spPr>
+        <p:txBody>
+          <a:bodyPr wrap="square" lIns="0" tIns="0" rIns="0" bIns="0" rtlCol="0" anchor="ctr"/>
+          <a:lstStyle/>
+          <a:p>
+            <a:pPr indent="0" marL="0">
+              <a:buNone/>
+            </a:pPr>
+            <a:r>
+              <a:rPr lang="en-US" sz="2600" b="1" dirty="0">
                 <a:solidFill>
                   <a:srgbClr val="2F3C7E"/>
                 </a:solidFill>
@@ -8529,7 +10304,7 @@
               </a:rPr>
               <a:t>24.3%</a:t>
             </a:r>
-            <a:endParaRPr lang="en-US" sz="3400" dirty="0"/>
+            <a:endParaRPr lang="en-US" sz="2600" dirty="0"/>
           </a:p>
         </p:txBody>
       </p:sp>
@@ -8541,27 +10316,24 @@
         </p:nvSpPr>
         <p:spPr>
           <a:xfrm>
-            <a:off x="4480560" y="2606040"/>
-            <a:ext cx="3017520" cy="640080"/>
-          </a:xfrm>
-          <a:prstGeom prst="rect">
-            <a:avLst/>
-          </a:prstGeom>
-          <a:noFill/>
-          <a:ln/>
-        </p:spPr>
-        <p:txBody>
-          <a:bodyPr wrap="square" lIns="0" tIns="0" rIns="0" bIns="0" rtlCol="0" anchor="ctr"/>
-          <a:lstStyle/>
-          <a:p>
-            <a:pPr indent="0" marL="0">
-              <a:lnSpc>
-                <a:spcPct val="120000"/>
-              </a:lnSpc>
-              <a:buNone/>
-            </a:pPr>
-            <a:r>
-              <a:rPr lang="en-US" sz="1150" dirty="0">
+            <a:off x="4480560" y="2240280"/>
+            <a:ext cx="3017520" cy="365760"/>
+          </a:xfrm>
+          <a:prstGeom prst="rect">
+            <a:avLst/>
+          </a:prstGeom>
+          <a:noFill/>
+          <a:ln/>
+        </p:spPr>
+        <p:txBody>
+          <a:bodyPr wrap="square" lIns="0" tIns="0" rIns="0" bIns="0" rtlCol="0" anchor="ctr"/>
+          <a:lstStyle/>
+          <a:p>
+            <a:pPr indent="0" marL="0">
+              <a:buNone/>
+            </a:pPr>
+            <a:r>
+              <a:rPr lang="en-US" sz="1100" dirty="0">
                 <a:solidFill>
                   <a:srgbClr val="6B7280"/>
                 </a:solidFill>
@@ -8569,9 +10341,9 @@
                 <a:ea typeface="Calibri" pitchFamily="34" charset="-122"/>
                 <a:cs typeface="Calibri" pitchFamily="34" charset="-120"/>
               </a:rPr>
-              <a:t>CAGR through 2031 (Mordor Intelligence)</a:t>
-            </a:r>
-            <a:endParaRPr lang="en-US" sz="1150" dirty="0"/>
+              <a:t>India CAGR through 2031</a:t>
+            </a:r>
+            <a:endParaRPr lang="en-US" sz="1100" dirty="0"/>
           </a:p>
         </p:txBody>
       </p:sp>
@@ -8583,12 +10355,12 @@
         </p:nvSpPr>
         <p:spPr>
           <a:xfrm>
-            <a:off x="7955280" y="1783080"/>
-            <a:ext cx="3474720" cy="1554480"/>
+            <a:off x="7955280" y="1645920"/>
+            <a:ext cx="3474720" cy="1051560"/>
           </a:xfrm>
           <a:prstGeom prst="roundRect">
             <a:avLst>
-              <a:gd name="adj" fmla="val 5882"/>
+              <a:gd name="adj" fmla="val 8696"/>
             </a:avLst>
           </a:prstGeom>
           <a:solidFill>
@@ -8610,24 +10382,24 @@
         </p:nvSpPr>
         <p:spPr>
           <a:xfrm>
-            <a:off x="8183880" y="1920240"/>
-            <a:ext cx="3017520" cy="685800"/>
-          </a:xfrm>
-          <a:prstGeom prst="rect">
-            <a:avLst/>
-          </a:prstGeom>
-          <a:noFill/>
-          <a:ln/>
-        </p:spPr>
-        <p:txBody>
-          <a:bodyPr wrap="square" lIns="0" tIns="0" rIns="0" bIns="0" rtlCol="0" anchor="ctr"/>
-          <a:lstStyle/>
-          <a:p>
-            <a:pPr indent="0" marL="0">
-              <a:buNone/>
-            </a:pPr>
-            <a:r>
-              <a:rPr lang="en-US" sz="3400" b="1" dirty="0">
+            <a:off x="8183880" y="1719072"/>
+            <a:ext cx="3017520" cy="502920"/>
+          </a:xfrm>
+          <a:prstGeom prst="rect">
+            <a:avLst/>
+          </a:prstGeom>
+          <a:noFill/>
+          <a:ln/>
+        </p:spPr>
+        <p:txBody>
+          <a:bodyPr wrap="square" lIns="0" tIns="0" rIns="0" bIns="0" rtlCol="0" anchor="ctr"/>
+          <a:lstStyle/>
+          <a:p>
+            <a:pPr indent="0" marL="0">
+              <a:buNone/>
+            </a:pPr>
+            <a:r>
+              <a:rPr lang="en-US" sz="2600" b="1" dirty="0">
                 <a:solidFill>
                   <a:srgbClr val="2F3C7E"/>
                 </a:solidFill>
@@ -8637,7 +10409,7 @@
               </a:rPr>
               <a:t>$322.1B</a:t>
             </a:r>
-            <a:endParaRPr lang="en-US" sz="3400" dirty="0"/>
+            <a:endParaRPr lang="en-US" sz="2600" dirty="0"/>
           </a:p>
         </p:txBody>
       </p:sp>
@@ -8649,27 +10421,24 @@
         </p:nvSpPr>
         <p:spPr>
           <a:xfrm>
-            <a:off x="8183880" y="2606040"/>
-            <a:ext cx="3017520" cy="640080"/>
-          </a:xfrm>
-          <a:prstGeom prst="rect">
-            <a:avLst/>
-          </a:prstGeom>
-          <a:noFill/>
-          <a:ln/>
-        </p:spPr>
-        <p:txBody>
-          <a:bodyPr wrap="square" lIns="0" tIns="0" rIns="0" bIns="0" rtlCol="0" anchor="ctr"/>
-          <a:lstStyle/>
-          <a:p>
-            <a:pPr indent="0" marL="0">
-              <a:lnSpc>
-                <a:spcPct val="120000"/>
-              </a:lnSpc>
-              <a:buNone/>
-            </a:pPr>
-            <a:r>
-              <a:rPr lang="en-US" sz="1150" dirty="0">
+            <a:off x="8183880" y="2240280"/>
+            <a:ext cx="3017520" cy="365760"/>
+          </a:xfrm>
+          <a:prstGeom prst="rect">
+            <a:avLst/>
+          </a:prstGeom>
+          <a:noFill/>
+          <a:ln/>
+        </p:spPr>
+        <p:txBody>
+          <a:bodyPr wrap="square" lIns="0" tIns="0" rIns="0" bIns="0" rtlCol="0" anchor="ctr"/>
+          <a:lstStyle/>
+          <a:p>
+            <a:pPr indent="0" marL="0">
+              <a:buNone/>
+            </a:pPr>
+            <a:r>
+              <a:rPr lang="en-US" sz="1100" dirty="0">
                 <a:solidFill>
                   <a:srgbClr val="6B7280"/>
                 </a:solidFill>
@@ -8677,9 +10446,9 @@
                 <a:ea typeface="Calibri" pitchFamily="34" charset="-122"/>
                 <a:cs typeface="Calibri" pitchFamily="34" charset="-120"/>
               </a:rPr>
-              <a:t>Projected India D2C market by 2031</a:t>
-            </a:r>
-            <a:endParaRPr lang="en-US" sz="1150" dirty="0"/>
+              <a:t>India market, 2031</a:t>
+            </a:r>
+            <a:endParaRPr lang="en-US" sz="1100" dirty="0"/>
           </a:p>
         </p:txBody>
       </p:sp>
@@ -8691,12 +10460,133 @@
         </p:nvSpPr>
         <p:spPr>
           <a:xfrm>
-            <a:off x="548640" y="3566160"/>
-            <a:ext cx="10835640" cy="2423160"/>
+            <a:off x="548640" y="2880360"/>
+            <a:ext cx="5349240" cy="3246120"/>
           </a:xfrm>
           <a:prstGeom prst="roundRect">
             <a:avLst>
-              <a:gd name="adj" fmla="val 4528"/>
+              <a:gd name="adj" fmla="val 3380"/>
+            </a:avLst>
+          </a:prstGeom>
+          <a:solidFill>
+            <a:srgbClr val="F7F7F6"/>
+          </a:solidFill>
+          <a:ln w="12700">
+            <a:solidFill>
+              <a:srgbClr val="E4E4EC"/>
+            </a:solidFill>
+            <a:prstDash val="solid"/>
+          </a:ln>
+        </p:spPr>
+      </p:sp>
+      <p:sp>
+        <p:nvSpPr>
+          <p:cNvPr id="14" name="Text 12"/>
+          <p:cNvSpPr txBox="1"/>
+          <p:nvPr/>
+        </p:nvSpPr>
+        <p:spPr>
+          <a:xfrm>
+            <a:off x="777240" y="3044952"/>
+            <a:ext cx="4892040" cy="274320"/>
+          </a:xfrm>
+          <a:prstGeom prst="rect">
+            <a:avLst/>
+          </a:prstGeom>
+          <a:noFill/>
+          <a:ln/>
+        </p:spPr>
+        <p:txBody>
+          <a:bodyPr wrap="square" lIns="0" tIns="0" rIns="0" bIns="0" rtlCol="0" anchor="ctr"/>
+          <a:lstStyle/>
+          <a:p>
+            <a:pPr indent="0" marL="0">
+              <a:buNone/>
+            </a:pPr>
+            <a:r>
+              <a:rPr lang="en-US" sz="1050" b="1" spc="100" kern="0" dirty="0">
+                <a:solidFill>
+                  <a:srgbClr val="6B7280"/>
+                </a:solidFill>
+                <a:latin typeface="Calibri" pitchFamily="34" charset="0"/>
+                <a:ea typeface="Calibri" pitchFamily="34" charset="-122"/>
+                <a:cs typeface="Calibri" pitchFamily="34" charset="-120"/>
+              </a:rPr>
+              <a:t>INDIA D2C MARKET, MODELED 2026–2031</a:t>
+            </a:r>
+            <a:endParaRPr lang="en-US" sz="1050" dirty="0"/>
+          </a:p>
+        </p:txBody>
+      </p:sp>
+      <p:graphicFrame>
+        <p:nvGraphicFramePr>
+          <p:cNvPr id="15" name="Chart 0" descr=""/>
+          <p:cNvGraphicFramePr/>
+          <p:nvPr/>
+        </p:nvGraphicFramePr>
+        <p:xfrm>
+          <a:off x="731520" y="3383280"/>
+          <a:ext cx="4983480" cy="2377440"/>
+        </p:xfrm>
+        <a:graphic xmlns:a="http://schemas.openxmlformats.org/drawingml/2006/main">
+          <a:graphicData uri="http://schemas.openxmlformats.org/drawingml/2006/chart">
+            <c:chart xmlns:c="http://schemas.openxmlformats.org/drawingml/2006/chart" r:id="rId1"/>
+          </a:graphicData>
+        </a:graphic>
+      </p:graphicFrame>
+      <p:sp>
+        <p:nvSpPr>
+          <p:cNvPr id="16" name="Text 13"/>
+          <p:cNvSpPr txBox="1"/>
+          <p:nvPr/>
+        </p:nvSpPr>
+        <p:spPr>
+          <a:xfrm>
+            <a:off x="777240" y="5742432"/>
+            <a:ext cx="4892040" cy="365760"/>
+          </a:xfrm>
+          <a:prstGeom prst="rect">
+            <a:avLst/>
+          </a:prstGeom>
+          <a:noFill/>
+          <a:ln/>
+        </p:spPr>
+        <p:txBody>
+          <a:bodyPr wrap="square" lIns="0" tIns="0" rIns="0" bIns="0" rtlCol="0" anchor="ctr"/>
+          <a:lstStyle/>
+          <a:p>
+            <a:pPr indent="0" marL="0">
+              <a:buNone/>
+            </a:pPr>
+            <a:r>
+              <a:rPr lang="en-US" sz="900" i="1" dirty="0">
+                <a:solidFill>
+                  <a:srgbClr val="6B7280"/>
+                </a:solidFill>
+                <a:latin typeface="Calibri" pitchFamily="34" charset="0"/>
+                <a:ea typeface="Calibri" pitchFamily="34" charset="-122"/>
+                <a:cs typeface="Calibri" pitchFamily="34" charset="-120"/>
+              </a:rPr>
+              <a:t>Modeled from the two verified endpoints (2026, 2031) using Mordor Intelligence's 24.3% CAGR — not a year-by-year reported figure.</a:t>
+            </a:r>
+            <a:endParaRPr lang="en-US" sz="900" dirty="0"/>
+          </a:p>
+        </p:txBody>
+      </p:sp>
+      <p:sp>
+        <p:nvSpPr>
+          <p:cNvPr id="17" name="Shape 14"/>
+          <p:cNvSpPr/>
+          <p:nvPr/>
+        </p:nvSpPr>
+        <p:spPr>
+          <a:xfrm>
+            <a:off x="6080760" y="2880360"/>
+            <a:ext cx="5303520" cy="3246120"/>
+          </a:xfrm>
+          <a:prstGeom prst="roundRect">
+            <a:avLst>
+              <a:gd name="adj" fmla="val 3380"/>
             </a:avLst>
           </a:prstGeom>
           <a:solidFill>
@@ -8707,30 +10597,30 @@
       </p:sp>
       <p:sp>
         <p:nvSpPr>
-          <p:cNvPr id="14" name="Text 12"/>
-          <p:cNvSpPr txBox="1"/>
-          <p:nvPr/>
-        </p:nvSpPr>
-        <p:spPr>
-          <a:xfrm>
-            <a:off x="822960" y="3749040"/>
-            <a:ext cx="7315200" cy="320040"/>
-          </a:xfrm>
-          <a:prstGeom prst="rect">
-            <a:avLst/>
-          </a:prstGeom>
-          <a:noFill/>
-          <a:ln/>
-        </p:spPr>
-        <p:txBody>
-          <a:bodyPr wrap="square" lIns="0" tIns="0" rIns="0" bIns="0" rtlCol="0" anchor="ctr"/>
-          <a:lstStyle/>
-          <a:p>
-            <a:pPr indent="0" marL="0">
-              <a:buNone/>
-            </a:pPr>
-            <a:r>
-              <a:rPr lang="en-US" sz="1100" b="1" spc="120" kern="0" dirty="0">
+          <p:cNvPr id="18" name="Text 15"/>
+          <p:cNvSpPr txBox="1"/>
+          <p:nvPr/>
+        </p:nvSpPr>
+        <p:spPr>
+          <a:xfrm>
+            <a:off x="6355080" y="3081528"/>
+            <a:ext cx="4754880" cy="292608"/>
+          </a:xfrm>
+          <a:prstGeom prst="rect">
+            <a:avLst/>
+          </a:prstGeom>
+          <a:noFill/>
+          <a:ln/>
+        </p:spPr>
+        <p:txBody>
+          <a:bodyPr wrap="square" lIns="0" tIns="0" rIns="0" bIns="0" rtlCol="0" anchor="ctr"/>
+          <a:lstStyle/>
+          <a:p>
+            <a:pPr indent="0" marL="0">
+              <a:buNone/>
+            </a:pPr>
+            <a:r>
+              <a:rPr lang="en-US" sz="1050" b="1" spc="100" kern="0" dirty="0">
                 <a:solidFill>
                   <a:srgbClr val="F9E795"/>
                 </a:solidFill>
@@ -8740,20 +10630,20 @@
               </a:rPr>
               <a:t>BOTTOM-UP: SOFTWARE SPEND, NOT GMV</a:t>
             </a:r>
-            <a:endParaRPr lang="en-US" sz="1100" dirty="0"/>
-          </a:p>
-        </p:txBody>
-      </p:sp>
-      <p:sp>
-        <p:nvSpPr>
-          <p:cNvPr id="15" name="Text 13"/>
-          <p:cNvSpPr txBox="1"/>
-          <p:nvPr/>
-        </p:nvSpPr>
-        <p:spPr>
-          <a:xfrm>
-            <a:off x="822960" y="4114800"/>
-            <a:ext cx="6583680" cy="1371600"/>
+            <a:endParaRPr lang="en-US" sz="1050" dirty="0"/>
+          </a:p>
+        </p:txBody>
+      </p:sp>
+      <p:sp>
+        <p:nvSpPr>
+          <p:cNvPr id="19" name="Text 16"/>
+          <p:cNvSpPr txBox="1"/>
+          <p:nvPr/>
+        </p:nvSpPr>
+        <p:spPr>
+          <a:xfrm>
+            <a:off x="6355080" y="3447288"/>
+            <a:ext cx="4754880" cy="1234440"/>
           </a:xfrm>
           <a:prstGeom prst="rect">
             <a:avLst/>
@@ -8767,12 +10657,12 @@
           <a:p>
             <a:pPr indent="0" marL="0">
               <a:lnSpc>
-                <a:spcPct val="130000"/>
+                <a:spcPct val="128000"/>
               </a:lnSpc>
               <a:buNone/>
             </a:pPr>
             <a:r>
-              <a:rPr lang="en-US" sz="1300" dirty="0">
+              <a:rPr lang="en-US" sz="1250" dirty="0">
                 <a:solidFill>
                   <a:srgbClr val="C9CEE8"/>
                 </a:solidFill>
@@ -8782,26 +10672,26 @@
               </a:rPr>
               <a:t>The figures above describe the market our customers sell into — not a verified SaaS-tool spend estimate. Benchmarked against Triple Whale ($124–$375+/mo) and Putler ($20–$750/mo), a defensible entry price for the ₹10L–₹4Cr/month D2C segment is roughly $50–$300/month per brand.</a:t>
             </a:r>
-            <a:endParaRPr lang="en-US" sz="1300" dirty="0"/>
-          </a:p>
-        </p:txBody>
-      </p:sp>
-      <p:sp>
-        <p:nvSpPr>
-          <p:cNvPr id="16" name="Shape 14"/>
+            <a:endParaRPr lang="en-US" sz="1250" dirty="0"/>
+          </a:p>
+        </p:txBody>
+      </p:sp>
+      <p:sp>
+        <p:nvSpPr>
+          <p:cNvPr id="20" name="Shape 17"/>
           <p:cNvSpPr/>
           <p:nvPr/>
         </p:nvSpPr>
         <p:spPr>
           <a:xfrm>
-            <a:off x="7680960" y="3794760"/>
-            <a:ext cx="914" cy="1965960"/>
+            <a:off x="6355080" y="4754880"/>
+            <a:ext cx="4754880" cy="914"/>
           </a:xfrm>
           <a:prstGeom prst="line">
             <a:avLst/>
           </a:prstGeom>
           <a:noFill/>
-          <a:ln w="19050">
+          <a:ln w="12700">
             <a:solidFill>
               <a:srgbClr val="3E4A87"/>
             </a:solidFill>
@@ -8811,30 +10701,30 @@
       </p:sp>
       <p:sp>
         <p:nvSpPr>
-          <p:cNvPr id="17" name="Text 15"/>
-          <p:cNvSpPr txBox="1"/>
-          <p:nvPr/>
-        </p:nvSpPr>
-        <p:spPr>
-          <a:xfrm>
-            <a:off x="7955280" y="3977640"/>
-            <a:ext cx="3200400" cy="502920"/>
-          </a:xfrm>
-          <a:prstGeom prst="rect">
-            <a:avLst/>
-          </a:prstGeom>
-          <a:noFill/>
-          <a:ln/>
-        </p:spPr>
-        <p:txBody>
-          <a:bodyPr wrap="square" lIns="0" tIns="0" rIns="0" bIns="0" rtlCol="0" anchor="ctr"/>
-          <a:lstStyle/>
-          <a:p>
-            <a:pPr indent="0" marL="0">
-              <a:buNone/>
-            </a:pPr>
-            <a:r>
-              <a:rPr lang="en-US" sz="2400" b="1" dirty="0">
+          <p:cNvPr id="21" name="Text 18"/>
+          <p:cNvSpPr txBox="1"/>
+          <p:nvPr/>
+        </p:nvSpPr>
+        <p:spPr>
+          <a:xfrm>
+            <a:off x="6355080" y="4892040"/>
+            <a:ext cx="4754880" cy="457200"/>
+          </a:xfrm>
+          <a:prstGeom prst="rect">
+            <a:avLst/>
+          </a:prstGeom>
+          <a:noFill/>
+          <a:ln/>
+        </p:spPr>
+        <p:txBody>
+          <a:bodyPr wrap="square" lIns="0" tIns="0" rIns="0" bIns="0" rtlCol="0" anchor="ctr"/>
+          <a:lstStyle/>
+          <a:p>
+            <a:pPr indent="0" marL="0">
+              <a:buNone/>
+            </a:pPr>
+            <a:r>
+              <a:rPr lang="en-US" sz="2200" b="1" dirty="0">
                 <a:solidFill>
                   <a:srgbClr val="FFFFFF"/>
                 </a:solidFill>
@@ -8844,20 +10734,20 @@
               </a:rPr>
               <a:t>~800–2,500</a:t>
             </a:r>
-            <a:endParaRPr lang="en-US" sz="2400" dirty="0"/>
-          </a:p>
-        </p:txBody>
-      </p:sp>
-      <p:sp>
-        <p:nvSpPr>
-          <p:cNvPr id="18" name="Text 16"/>
-          <p:cNvSpPr txBox="1"/>
-          <p:nvPr/>
-        </p:nvSpPr>
-        <p:spPr>
-          <a:xfrm>
-            <a:off x="7955280" y="4526280"/>
-            <a:ext cx="3200400" cy="1188720"/>
+            <a:endParaRPr lang="en-US" sz="2200" dirty="0"/>
+          </a:p>
+        </p:txBody>
+      </p:sp>
+      <p:sp>
+        <p:nvSpPr>
+          <p:cNvPr id="22" name="Text 19"/>
+          <p:cNvSpPr txBox="1"/>
+          <p:nvPr/>
+        </p:nvSpPr>
+        <p:spPr>
+          <a:xfrm>
+            <a:off x="6355080" y="5367528"/>
+            <a:ext cx="4754880" cy="685800"/>
           </a:xfrm>
           <a:prstGeom prst="rect">
             <a:avLst/>
@@ -8876,7 +10766,7 @@
               <a:buNone/>
             </a:pPr>
             <a:r>
-              <a:rPr lang="en-US" sz="1100" i="1" dirty="0">
+              <a:rPr lang="en-US" sz="1050" i="1" dirty="0">
                 <a:solidFill>
                   <a:srgbClr val="C9CEE8"/>
                 </a:solidFill>
@@ -8886,36 +10776,36 @@
               </a:rPr>
               <a:t>illustrative estimate of funded/scaling Indian D2C brands in the addressable revenue band — needs validation, not a sourced figure</a:t>
             </a:r>
-            <a:endParaRPr lang="en-US" sz="1100" dirty="0"/>
-          </a:p>
-        </p:txBody>
-      </p:sp>
-      <p:sp>
-        <p:nvSpPr>
-          <p:cNvPr id="19" name="Text 17"/>
-          <p:cNvSpPr txBox="1"/>
-          <p:nvPr/>
-        </p:nvSpPr>
-        <p:spPr>
-          <a:xfrm>
-            <a:off x="548640" y="6172200"/>
-            <a:ext cx="10881360" cy="365760"/>
-          </a:xfrm>
-          <a:prstGeom prst="rect">
-            <a:avLst/>
-          </a:prstGeom>
-          <a:noFill/>
-          <a:ln/>
-        </p:spPr>
-        <p:txBody>
-          <a:bodyPr wrap="square" lIns="0" tIns="0" rIns="0" bIns="0" rtlCol="0" anchor="ctr"/>
-          <a:lstStyle/>
-          <a:p>
-            <a:pPr indent="0" marL="0">
-              <a:buNone/>
-            </a:pPr>
-            <a:r>
-              <a:rPr lang="en-US" sz="1050" dirty="0">
+            <a:endParaRPr lang="en-US" sz="1050" dirty="0"/>
+          </a:p>
+        </p:txBody>
+      </p:sp>
+      <p:sp>
+        <p:nvSpPr>
+          <p:cNvPr id="23" name="Text 20"/>
+          <p:cNvSpPr txBox="1"/>
+          <p:nvPr/>
+        </p:nvSpPr>
+        <p:spPr>
+          <a:xfrm>
+            <a:off x="548640" y="6236208"/>
+            <a:ext cx="10881360" cy="320040"/>
+          </a:xfrm>
+          <a:prstGeom prst="rect">
+            <a:avLst/>
+          </a:prstGeom>
+          <a:noFill/>
+          <a:ln/>
+        </p:spPr>
+        <p:txBody>
+          <a:bodyPr wrap="square" lIns="0" tIns="0" rIns="0" bIns="0" rtlCol="0" anchor="ctr"/>
+          <a:lstStyle/>
+          <a:p>
+            <a:pPr indent="0" marL="0">
+              <a:buNone/>
+            </a:pPr>
+            <a:r>
+              <a:rPr lang="en-US" sz="950" dirty="0">
                 <a:solidFill>
                   <a:srgbClr val="6B7280"/>
                 </a:solidFill>
@@ -8923,15 +10813,15 @@
                 <a:ea typeface="Calibri" pitchFamily="34" charset="-122"/>
                 <a:cs typeface="Calibri" pitchFamily="34" charset="-120"/>
               </a:rPr>
-              <a:t>Verified: Mordor Intelligence, India D2C E-commerce Market Analysis (2026). All figures beyond this are Priyam's own construction, flagged for what they are.</a:t>
-            </a:r>
-            <a:endParaRPr lang="en-US" sz="1050" dirty="0"/>
-          </a:p>
-        </p:txBody>
-      </p:sp>
-      <p:sp>
-        <p:nvSpPr>
-          <p:cNvPr id="20" name="Text 18"/>
+              <a:t>Verified: Mordor Intelligence, India D2C E-commerce Market Analysis (2026). Global context and expansion path: see the Roadmap slide. All figures beyond named sources are Priyam's own construction, flagged as such.</a:t>
+            </a:r>
+            <a:endParaRPr lang="en-US" sz="950" dirty="0"/>
+          </a:p>
+        </p:txBody>
+      </p:sp>
+      <p:sp>
+        <p:nvSpPr>
+          <p:cNvPr id="24" name="Text 21"/>
           <p:cNvSpPr txBox="1"/>
           <p:nvPr/>
         </p:nvSpPr>
@@ -8970,7 +10860,7 @@
       </p:sp>
       <p:sp>
         <p:nvSpPr>
-          <p:cNvPr id="21" name="Text 19"/>
+          <p:cNvPr id="25" name="Text 22"/>
           <p:cNvSpPr txBox="1"/>
           <p:nvPr/>
         </p:nvSpPr>

</xml_diff>